<commit_message>
Remove Week 1 lab artifacts from class materials
</commit_message>
<xml_diff>
--- a/week_01/week_01_responsibility_relational_thinking.pptx
+++ b/week_01/week_01_responsibility_relational_thinking.pptx
@@ -16,8 +16,6 @@
     <p:sldId xmlns:r="http://schemas.openxmlformats.org/officeDocument/2006/relationships" id="261" r:id="Rd60ac03b904845b8"/>
     <p:sldId xmlns:r="http://schemas.openxmlformats.org/officeDocument/2006/relationships" id="262" r:id="R759c7d7bd9ab499c"/>
     <p:sldId xmlns:r="http://schemas.openxmlformats.org/officeDocument/2006/relationships" id="263" r:id="R6eb70e108e3e4f36"/>
-    <p:sldId xmlns:r="http://schemas.openxmlformats.org/officeDocument/2006/relationships" id="264" r:id="R3235a524ca774343"/>
-    <p:sldId xmlns:r="http://schemas.openxmlformats.org/officeDocument/2006/relationships" id="265" r:id="R2be97a786e7e46d3"/>
     <p:sldId xmlns:r="http://schemas.openxmlformats.org/officeDocument/2006/relationships" id="266" r:id="R297a0ce4cac84d7e"/>
     <p:sldId xmlns:r="http://schemas.openxmlformats.org/officeDocument/2006/relationships" id="267" r:id="Rb581964e8b7740c2"/>
     <p:sldId xmlns:r="http://schemas.openxmlformats.org/officeDocument/2006/relationships" id="268" r:id="Reeef7012e8d5445c"/>
@@ -26,7 +24,6 @@
     <p:sldId xmlns:r="http://schemas.openxmlformats.org/officeDocument/2006/relationships" id="271" r:id="Ra5d8d13c5b7d4059"/>
     <p:sldId xmlns:r="http://schemas.openxmlformats.org/officeDocument/2006/relationships" id="272" r:id="R2a769ebbfec64cd2"/>
     <p:sldId xmlns:r="http://schemas.openxmlformats.org/officeDocument/2006/relationships" id="273" r:id="R40f11e2acd5a4421"/>
-    <p:sldId xmlns:r="http://schemas.openxmlformats.org/officeDocument/2006/relationships" id="274" r:id="Rfa1227e93d5c4d53"/>
     <p:sldId xmlns:r="http://schemas.openxmlformats.org/officeDocument/2006/relationships" id="275" r:id="R5b7b75f8030e4e30"/>
   </p:sldIdLst>
   <p:sldSz cx="12192000" cy="6858000"/>
@@ -511,91 +508,6 @@
 </p:notes>
 </file>
 
-<file path=ppt/notesSlides/notesSlide10.xml><?xml version="1.0" encoding="utf-8"?>
-<p:notes xmlns:p="http://schemas.openxmlformats.org/presentationml/2006/main">
-  <p:cSld>
-    <p:spTree>
-      <p:nvGrpSpPr>
-        <p:cNvPr id="1" name=""/>
-        <p:cNvGrpSpPr/>
-        <p:nvPr/>
-      </p:nvGrpSpPr>
-      <p:grpSpPr>
-        <a:xfrm xmlns:a="http://schemas.openxmlformats.org/drawingml/2006/main"/>
-      </p:grpSpPr>
-      <p:sp>
-        <p:nvSpPr>
-          <p:cNvPr id="2" name="Slide Image Placeholder 1"/>
-          <p:cNvSpPr>
-            <a:spLocks xmlns:a="http://schemas.openxmlformats.org/drawingml/2006/main" noGrp="1"/>
-          </p:cNvSpPr>
-          <p:nvPr>
-            <p:ph type="sldImg" idx="0"/>
-          </p:nvPr>
-        </p:nvSpPr>
-        <p:spPr/>
-      </p:sp>
-      <p:sp>
-        <p:nvSpPr>
-          <p:cNvPr id="3" name="Notes Placeholder 2"/>
-          <p:cNvSpPr>
-            <a:spLocks xmlns:a="http://schemas.openxmlformats.org/drawingml/2006/main" noGrp="1"/>
-          </p:cNvSpPr>
-          <p:nvPr>
-            <p:ph type="body" idx="1"/>
-          </p:nvPr>
-        </p:nvSpPr>
-        <p:spPr/>
-        <p:txBody>
-          <a:bodyPr xmlns:a="http://schemas.openxmlformats.org/drawingml/2006/main"/>
-          <a:lstStyle xmlns:a="http://schemas.openxmlformats.org/drawingml/2006/main"/>
-          <a:p xmlns:a="http://schemas.openxmlformats.org/drawingml/2006/main">
-            <a:r>
-              <a:t>The first lab turns the system path into a concrete design. Choose one familiar application: a music service, an online store, a game, or a public service. Create the file named app_database_map.md inside the week_01 folder. Begin by listing the important information the application must remember. Then write three questions the application must answer, because useful schemas are shaped by useful questions. Next, trace one action from the client through the API, identity checks, the DBMS, and stored data. Finally, sketch one possible table and one possible JSON document for a small part of the same application. These are early designs, so they do not need to be complete. The assignment is individual and has one submission: the GitHub URL for the completed Markdown file.</a:t>
-            </a:r>
-          </a:p>
-          <a:p xmlns:a="http://schemas.openxmlformats.org/drawingml/2006/main">
-            <a:r>
-              <a:t/>
-            </a:r>
-          </a:p>
-          <a:p xmlns:a="http://schemas.openxmlformats.org/drawingml/2006/main">
-            <a:r>
-              <a:t>[Sources]</a:t>
-            </a:r>
-          </a:p>
-          <a:p xmlns:a="http://schemas.openxmlformats.org/drawingml/2006/main">
-            <a:r>
-              <a:t>- CST4714 Week 1 Lab 1: Map an Application to Its Database.</a:t>
-            </a:r>
-          </a:p>
-        </p:txBody>
-      </p:sp>
-      <p:sp>
-        <p:nvSpPr>
-          <p:cNvPr id="4" name="Slide Number Placeholder 3"/>
-          <p:cNvSpPr>
-            <a:spLocks xmlns:a="http://schemas.openxmlformats.org/drawingml/2006/main" noGrp="1"/>
-          </p:cNvSpPr>
-          <p:nvPr>
-            <p:ph type="sldNum" idx="5"/>
-          </p:nvPr>
-        </p:nvSpPr>
-        <p:spPr/>
-        <p:txBody>
-          <a:bodyPr xmlns:a="http://schemas.openxmlformats.org/drawingml/2006/main"/>
-          <a:lstStyle xmlns:a="http://schemas.openxmlformats.org/drawingml/2006/main"/>
-          <a:p xmlns:a="http://schemas.openxmlformats.org/drawingml/2006/main"/>
-        </p:txBody>
-      </p:sp>
-    </p:spTree>
-  </p:cSld>
-  <p:clrMapOvr>
-    <a:masterClrMapping xmlns:a="http://schemas.openxmlformats.org/drawingml/2006/main"/>
-  </p:clrMapOvr>
-</p:notes>
-</file>
-
 <file path=ppt/notesSlides/notesSlide11.xml><?xml version="1.0" encoding="utf-8"?>
 <p:notes xmlns:p="http://schemas.openxmlformats.org/presentationml/2006/main">
   <p:cSld>
@@ -1311,91 +1223,6 @@
 </p:notes>
 </file>
 
-<file path=ppt/notesSlides/notesSlide19.xml><?xml version="1.0" encoding="utf-8"?>
-<p:notes xmlns:p="http://schemas.openxmlformats.org/presentationml/2006/main">
-  <p:cSld>
-    <p:spTree>
-      <p:nvGrpSpPr>
-        <p:cNvPr id="1" name=""/>
-        <p:cNvGrpSpPr/>
-        <p:nvPr/>
-      </p:nvGrpSpPr>
-      <p:grpSpPr>
-        <a:xfrm xmlns:a="http://schemas.openxmlformats.org/drawingml/2006/main"/>
-      </p:grpSpPr>
-      <p:sp>
-        <p:nvSpPr>
-          <p:cNvPr id="2" name="Slide Image Placeholder 1"/>
-          <p:cNvSpPr>
-            <a:spLocks xmlns:a="http://schemas.openxmlformats.org/drawingml/2006/main" noGrp="1"/>
-          </p:cNvSpPr>
-          <p:nvPr>
-            <p:ph type="sldImg" idx="0"/>
-          </p:nvPr>
-        </p:nvSpPr>
-        <p:spPr/>
-      </p:sp>
-      <p:sp>
-        <p:nvSpPr>
-          <p:cNvPr id="3" name="Notes Placeholder 2"/>
-          <p:cNvSpPr>
-            <a:spLocks xmlns:a="http://schemas.openxmlformats.org/drawingml/2006/main" noGrp="1"/>
-          </p:cNvSpPr>
-          <p:nvPr>
-            <p:ph type="body" idx="1"/>
-          </p:nvPr>
-        </p:nvSpPr>
-        <p:spPr/>
-        <p:txBody>
-          <a:bodyPr xmlns:a="http://schemas.openxmlformats.org/drawingml/2006/main"/>
-          <a:lstStyle xmlns:a="http://schemas.openxmlformats.org/drawingml/2006/main"/>
-          <a:p xmlns:a="http://schemas.openxmlformats.org/drawingml/2006/main">
-            <a:r>
-              <a:t>The second lab practices the connection between a question, a relational operation, and SQL. Use the users and tickets relations shown in today’s materials. In Part A, read three provided relational expressions. For each expression, identify the output attributes and the tuples that would appear. Writing the output relation is the clearest way to verify your interpretation. In Part B, start from two plain-language questions. Write a relational algebra expression using the symbols sigma, pi, and join as needed, then write corresponding SQL. No database connection is required because the purpose is logical reasoning, not command execution. Complete the work individually in relational_reasoning.md and submit the GitHub URL for that single file before leaving class.</a:t>
-            </a:r>
-          </a:p>
-          <a:p xmlns:a="http://schemas.openxmlformats.org/drawingml/2006/main">
-            <a:r>
-              <a:t/>
-            </a:r>
-          </a:p>
-          <a:p xmlns:a="http://schemas.openxmlformats.org/drawingml/2006/main">
-            <a:r>
-              <a:t>[Sources]</a:t>
-            </a:r>
-          </a:p>
-          <a:p xmlns:a="http://schemas.openxmlformats.org/drawingml/2006/main">
-            <a:r>
-              <a:t>- CST4714 Week 1 Lab 2: Relational Reasoning Without a Database.</a:t>
-            </a:r>
-          </a:p>
-        </p:txBody>
-      </p:sp>
-      <p:sp>
-        <p:nvSpPr>
-          <p:cNvPr id="4" name="Slide Number Placeholder 3"/>
-          <p:cNvSpPr>
-            <a:spLocks xmlns:a="http://schemas.openxmlformats.org/drawingml/2006/main" noGrp="1"/>
-          </p:cNvSpPr>
-          <p:nvPr>
-            <p:ph type="sldNum" idx="5"/>
-          </p:nvPr>
-        </p:nvSpPr>
-        <p:spPr/>
-        <p:txBody>
-          <a:bodyPr xmlns:a="http://schemas.openxmlformats.org/drawingml/2006/main"/>
-          <a:lstStyle xmlns:a="http://schemas.openxmlformats.org/drawingml/2006/main"/>
-          <a:p xmlns:a="http://schemas.openxmlformats.org/drawingml/2006/main"/>
-        </p:txBody>
-      </p:sp>
-    </p:spTree>
-  </p:cSld>
-  <p:clrMapOvr>
-    <a:masterClrMapping xmlns:a="http://schemas.openxmlformats.org/drawingml/2006/main"/>
-  </p:clrMapOvr>
-</p:notes>
-</file>
-
 <file path=ppt/notesSlides/notesSlide2.xml><?xml version="1.0" encoding="utf-8"?>
 <p:notes xmlns:p="http://schemas.openxmlformats.org/presentationml/2006/main">
   <p:cSld>
@@ -2117,101 +1944,6 @@
           <a:p xmlns:a="http://schemas.openxmlformats.org/drawingml/2006/main">
             <a:r>
               <a:t>- https://developer.mozilla.org/en-US/docs/Web/HTTP/Status/201</a:t>
-            </a:r>
-          </a:p>
-        </p:txBody>
-      </p:sp>
-      <p:sp>
-        <p:nvSpPr>
-          <p:cNvPr id="4" name="Slide Number Placeholder 3"/>
-          <p:cNvSpPr>
-            <a:spLocks xmlns:a="http://schemas.openxmlformats.org/drawingml/2006/main" noGrp="1"/>
-          </p:cNvSpPr>
-          <p:nvPr>
-            <p:ph type="sldNum" idx="5"/>
-          </p:nvPr>
-        </p:nvSpPr>
-        <p:spPr/>
-        <p:txBody>
-          <a:bodyPr xmlns:a="http://schemas.openxmlformats.org/drawingml/2006/main"/>
-          <a:lstStyle xmlns:a="http://schemas.openxmlformats.org/drawingml/2006/main"/>
-          <a:p xmlns:a="http://schemas.openxmlformats.org/drawingml/2006/main"/>
-        </p:txBody>
-      </p:sp>
-    </p:spTree>
-  </p:cSld>
-  <p:clrMapOvr>
-    <a:masterClrMapping xmlns:a="http://schemas.openxmlformats.org/drawingml/2006/main"/>
-  </p:clrMapOvr>
-</p:notes>
-</file>
-
-<file path=ppt/notesSlides/notesSlide9.xml><?xml version="1.0" encoding="utf-8"?>
-<p:notes xmlns:p="http://schemas.openxmlformats.org/presentationml/2006/main">
-  <p:cSld>
-    <p:spTree>
-      <p:nvGrpSpPr>
-        <p:cNvPr id="1" name=""/>
-        <p:cNvGrpSpPr/>
-        <p:nvPr/>
-      </p:nvGrpSpPr>
-      <p:grpSpPr>
-        <a:xfrm xmlns:a="http://schemas.openxmlformats.org/drawingml/2006/main"/>
-      </p:grpSpPr>
-      <p:sp>
-        <p:nvSpPr>
-          <p:cNvPr id="2" name="Slide Image Placeholder 1"/>
-          <p:cNvSpPr>
-            <a:spLocks xmlns:a="http://schemas.openxmlformats.org/drawingml/2006/main" noGrp="1"/>
-          </p:cNvSpPr>
-          <p:nvPr>
-            <p:ph type="sldImg" idx="0"/>
-          </p:nvPr>
-        </p:nvSpPr>
-        <p:spPr/>
-      </p:sp>
-      <p:sp>
-        <p:nvSpPr>
-          <p:cNvPr id="3" name="Notes Placeholder 2"/>
-          <p:cNvSpPr>
-            <a:spLocks xmlns:a="http://schemas.openxmlformats.org/drawingml/2006/main" noGrp="1"/>
-          </p:cNvSpPr>
-          <p:nvPr>
-            <p:ph type="body" idx="1"/>
-          </p:nvPr>
-        </p:nvSpPr>
-        <p:spPr/>
-        <p:txBody>
-          <a:bodyPr xmlns:a="http://schemas.openxmlformats.org/drawingml/2006/main"/>
-          <a:lstStyle xmlns:a="http://schemas.openxmlformats.org/drawingml/2006/main"/>
-          <a:p xmlns:a="http://schemas.openxmlformats.org/drawingml/2006/main">
-            <a:r>
-              <a:t>Today’s work can be completed entirely in GitHub’s browser interface. Open the assigned repository and navigate to the requested folder. GitHub provides two useful editing paths. The pencil button edits the current file, while pressing the period key opens the web editor for the repository. Create a Markdown file with the exact requested name. Markdown uses plain text conventions such as a hash mark for a heading, hyphens for lists, and triple backticks for code. Preview the rendered file before committing it. A commit records the change in the repository history. For submission, provide the URL of the completed file, not the editing screen. This workflow is intentionally small, but it introduces the same versioned writing process used for technical documentation, runbooks, schema notes, and project READMEs.</a:t>
-            </a:r>
-          </a:p>
-          <a:p xmlns:a="http://schemas.openxmlformats.org/drawingml/2006/main">
-            <a:r>
-              <a:t/>
-            </a:r>
-          </a:p>
-          <a:p xmlns:a="http://schemas.openxmlformats.org/drawingml/2006/main">
-            <a:r>
-              <a:t>[Sources]</a:t>
-            </a:r>
-          </a:p>
-          <a:p xmlns:a="http://schemas.openxmlformats.org/drawingml/2006/main">
-            <a:r>
-              <a:t>- CST4714 Week 1 Lab 1: Map an Application to Its Database.</a:t>
-            </a:r>
-          </a:p>
-          <a:p xmlns:a="http://schemas.openxmlformats.org/drawingml/2006/main">
-            <a:r>
-              <a:t>- https://docs.github.com/en/repositories/working-with-files/managing-files/editing-files</a:t>
-            </a:r>
-          </a:p>
-          <a:p xmlns:a="http://schemas.openxmlformats.org/drawingml/2006/main">
-            <a:r>
-              <a:t>- https://docs.github.com/en/codespaces/the-githubdev-web-based-editor</a:t>
             </a:r>
           </a:p>
         </p:txBody>
@@ -3420,1351 +3152,6 @@
 </p:sld>
 </file>
 
-<file path=ppt/slides/slide10.xml><?xml version="1.0" encoding="utf-8"?>
-<p:sld xmlns:p="http://schemas.openxmlformats.org/presentationml/2006/main">
-  <p:cSld>
-    <p:bg>
-      <p:bgPr>
-        <a:solidFill xmlns:a="http://schemas.openxmlformats.org/drawingml/2006/main">
-          <a:srgbClr val="F7F3EA"/>
-        </a:solidFill>
-      </p:bgPr>
-    </p:bg>
-    <p:spTree>
-      <p:nvGrpSpPr>
-        <p:cNvPr id="1" name=""/>
-        <p:cNvGrpSpPr/>
-        <p:nvPr/>
-      </p:nvGrpSpPr>
-      <p:grpSpPr>
-        <a:xfrm xmlns:a="http://schemas.openxmlformats.org/drawingml/2006/main"/>
-      </p:grpSpPr>
-      <p:sp>
-        <p:nvSpPr>
-          <p:cNvPr id="23" name="">
-            <a:extLst xmlns:a="http://schemas.openxmlformats.org/drawingml/2006/main">
-              <a:ext uri="{FF2B5EF4-FFF2-40B4-BE49-F238E27FC236}">
-                <a16:creationId xmlns:a16="http://schemas.microsoft.com/office/drawing/2014/main" id="{DAE4205D-6EA9-4857-BC69-EC9BBD0D2CF3}"/>
-              </a:ext>
-            </a:extLst>
-          </p:cNvPr>
-          <p:cNvSpPr>
-            <a:spLocks xmlns:a="http://schemas.openxmlformats.org/drawingml/2006/main" noGrp="1"/>
-          </p:cNvSpPr>
-          <p:nvPr/>
-        </p:nvSpPr>
-        <p:spPr>
-          <a:xfrm xmlns:a="http://schemas.openxmlformats.org/drawingml/2006/main">
-            <a:off x="552450" y="400050"/>
-            <a:ext cx="1447800" cy="323850"/>
-          </a:xfrm>
-          <a:prstGeom xmlns:a="http://schemas.openxmlformats.org/drawingml/2006/main" prst="roundRect">
-            <a:avLst>
-              <a:gd name="adj" fmla="val 50000"/>
-            </a:avLst>
-          </a:prstGeom>
-          <a:solidFill xmlns:a="http://schemas.openxmlformats.org/drawingml/2006/main">
-            <a:srgbClr val="14213D"/>
-          </a:solidFill>
-          <a:ln xmlns:a="http://schemas.openxmlformats.org/drawingml/2006/main" w="9525">
-            <a:solidFill>
-              <a:srgbClr val="14213D"/>
-            </a:solidFill>
-            <a:prstDash val="solid"/>
-          </a:ln>
-        </p:spPr>
-        <p:txBody>
-          <a:bodyPr xmlns:a="http://schemas.openxmlformats.org/drawingml/2006/main" lIns="76200" tIns="0" rIns="76200" bIns="0" anchor="ctr">
-            <a:normAutofit fontScale="100000"/>
-          </a:bodyPr>
-          <a:lstStyle xmlns:a="http://schemas.openxmlformats.org/drawingml/2006/main"/>
-          <a:p xmlns:a="http://schemas.openxmlformats.org/drawingml/2006/main">
-            <a:pPr algn="ctr">
-              <a:buNone/>
-              <a:defRPr sz="1050" b="1">
-                <a:solidFill>
-                  <a:srgbClr val="FFFFFF"/>
-                </a:solidFill>
-                <a:latin typeface="Avenir Next"/>
-                <a:ea typeface="Avenir Next"/>
-                <a:cs typeface="Avenir Next"/>
-              </a:defRPr>
-            </a:pPr>
-            <a:r>
-              <a:rPr sz="1050" b="1">
-                <a:solidFill>
-                  <a:srgbClr val="FFFFFF"/>
-                </a:solidFill>
-                <a:latin typeface="Avenir Next"/>
-                <a:ea typeface="Avenir Next"/>
-                <a:cs typeface="Avenir Next"/>
-              </a:rPr>
-              <a:t>IN-CLASS LAB</a:t>
-            </a:r>
-          </a:p>
-        </p:txBody>
-      </p:sp>
-      <p:sp>
-        <p:nvSpPr>
-          <p:cNvPr id="2" name="slide-title">
-            <a:extLst xmlns:a="http://schemas.openxmlformats.org/drawingml/2006/main">
-              <a:ext uri="{FF2B5EF4-FFF2-40B4-BE49-F238E27FC236}">
-                <a16:creationId xmlns:a16="http://schemas.microsoft.com/office/drawing/2014/main" id="{CB84EAC8-C1C4-4B33-9020-4B9BFD8AF54C}"/>
-              </a:ext>
-            </a:extLst>
-          </p:cNvPr>
-          <p:cNvSpPr>
-            <a:spLocks xmlns:a="http://schemas.openxmlformats.org/drawingml/2006/main" noGrp="1"/>
-          </p:cNvSpPr>
-          <p:nvPr/>
-        </p:nvSpPr>
-        <p:spPr>
-          <a:xfrm xmlns:a="http://schemas.openxmlformats.org/drawingml/2006/main">
-            <a:off x="552450" y="876300"/>
-            <a:ext cx="11087100" cy="704850"/>
-          </a:xfrm>
-          <a:prstGeom xmlns:a="http://schemas.openxmlformats.org/drawingml/2006/main" prst="rect">
-            <a:avLst/>
-          </a:prstGeom>
-          <a:noFill xmlns:a="http://schemas.openxmlformats.org/drawingml/2006/main"/>
-          <a:ln xmlns:a="http://schemas.openxmlformats.org/drawingml/2006/main" w="0">
-            <a:noFill/>
-            <a:prstDash val="solid"/>
-          </a:ln>
-        </p:spPr>
-        <p:txBody>
-          <a:bodyPr xmlns:a="http://schemas.openxmlformats.org/drawingml/2006/main" lIns="0" tIns="0" rIns="0" bIns="0" anchor="t">
-            <a:normAutofit fontScale="100000"/>
-          </a:bodyPr>
-          <a:lstStyle xmlns:a="http://schemas.openxmlformats.org/drawingml/2006/main"/>
-          <a:p xmlns:a="http://schemas.openxmlformats.org/drawingml/2006/main">
-            <a:pPr>
-              <a:lnSpc>
-                <a:spcPct val="95000"/>
-              </a:lnSpc>
-              <a:buNone/>
-              <a:defRPr sz="3000" b="1">
-                <a:solidFill>
-                  <a:srgbClr val="14213D"/>
-                </a:solidFill>
-                <a:latin typeface="Georgia"/>
-                <a:ea typeface="Georgia"/>
-                <a:cs typeface="Georgia"/>
-              </a:defRPr>
-            </a:pPr>
-            <a:r>
-              <a:rPr sz="3000" b="1">
-                <a:solidFill>
-                  <a:srgbClr val="14213D"/>
-                </a:solidFill>
-                <a:latin typeface="Georgia"/>
-                <a:ea typeface="Georgia"/>
-                <a:cs typeface="Georgia"/>
-              </a:rPr>
-              <a:t>Map one application to its database</a:t>
-            </a:r>
-          </a:p>
-        </p:txBody>
-      </p:sp>
-      <p:sp>
-        <p:nvSpPr>
-          <p:cNvPr id="3" name="">
-            <a:extLst xmlns:a="http://schemas.openxmlformats.org/drawingml/2006/main">
-              <a:ext uri="{FF2B5EF4-FFF2-40B4-BE49-F238E27FC236}">
-                <a16:creationId xmlns:a16="http://schemas.microsoft.com/office/drawing/2014/main" id="{5F1C88CB-DB3D-4984-AAEA-38F951EA0B42}"/>
-              </a:ext>
-            </a:extLst>
-          </p:cNvPr>
-          <p:cNvSpPr>
-            <a:spLocks xmlns:a="http://schemas.openxmlformats.org/drawingml/2006/main" noGrp="1"/>
-          </p:cNvSpPr>
-          <p:nvPr/>
-        </p:nvSpPr>
-        <p:spPr>
-          <a:xfrm xmlns:a="http://schemas.openxmlformats.org/drawingml/2006/main">
-            <a:off x="571500" y="1562100"/>
-            <a:ext cx="10477500" cy="381000"/>
-          </a:xfrm>
-          <a:prstGeom xmlns:a="http://schemas.openxmlformats.org/drawingml/2006/main" prst="rect">
-            <a:avLst/>
-          </a:prstGeom>
-          <a:noFill xmlns:a="http://schemas.openxmlformats.org/drawingml/2006/main"/>
-          <a:ln xmlns:a="http://schemas.openxmlformats.org/drawingml/2006/main" w="0">
-            <a:noFill/>
-            <a:prstDash val="solid"/>
-          </a:ln>
-        </p:spPr>
-        <p:txBody>
-          <a:bodyPr xmlns:a="http://schemas.openxmlformats.org/drawingml/2006/main" lIns="0" tIns="0" rIns="0" bIns="0" anchor="t">
-            <a:normAutofit fontScale="100000"/>
-          </a:bodyPr>
-          <a:lstStyle xmlns:a="http://schemas.openxmlformats.org/drawingml/2006/main"/>
-          <a:p xmlns:a="http://schemas.openxmlformats.org/drawingml/2006/main">
-            <a:pPr>
-              <a:buNone/>
-              <a:defRPr sz="1425">
-                <a:solidFill>
-                  <a:srgbClr val="5C6577"/>
-                </a:solidFill>
-                <a:latin typeface="Avenir Next"/>
-                <a:ea typeface="Avenir Next"/>
-                <a:cs typeface="Avenir Next"/>
-              </a:defRPr>
-            </a:pPr>
-            <a:r>
-              <a:rPr sz="1425">
-                <a:solidFill>
-                  <a:srgbClr val="5C6577"/>
-                </a:solidFill>
-                <a:latin typeface="Avenir Next"/>
-                <a:ea typeface="Avenir Next"/>
-                <a:cs typeface="Avenir Next"/>
-              </a:rPr>
-              <a:t>Individual work. One Markdown file. One submitted URL.</a:t>
-            </a:r>
-          </a:p>
-        </p:txBody>
-      </p:sp>
-      <p:sp>
-        <p:nvSpPr>
-          <p:cNvPr id="4" name="">
-            <a:extLst xmlns:a="http://schemas.openxmlformats.org/drawingml/2006/main">
-              <a:ext uri="{FF2B5EF4-FFF2-40B4-BE49-F238E27FC236}">
-                <a16:creationId xmlns:a16="http://schemas.microsoft.com/office/drawing/2014/main" id="{8780D8E9-26F3-4203-B29E-20A9C2AC574D}"/>
-              </a:ext>
-            </a:extLst>
-          </p:cNvPr>
-          <p:cNvSpPr>
-            <a:spLocks xmlns:a="http://schemas.openxmlformats.org/drawingml/2006/main" noGrp="1"/>
-          </p:cNvSpPr>
-          <p:nvPr/>
-        </p:nvSpPr>
-        <p:spPr>
-          <a:xfrm xmlns:a="http://schemas.openxmlformats.org/drawingml/2006/main">
-            <a:off x="11144250" y="6334125"/>
-            <a:ext cx="495300" cy="228600"/>
-          </a:xfrm>
-          <a:prstGeom xmlns:a="http://schemas.openxmlformats.org/drawingml/2006/main" prst="rect">
-            <a:avLst/>
-          </a:prstGeom>
-          <a:noFill xmlns:a="http://schemas.openxmlformats.org/drawingml/2006/main"/>
-          <a:ln xmlns:a="http://schemas.openxmlformats.org/drawingml/2006/main" w="0">
-            <a:noFill/>
-            <a:prstDash val="solid"/>
-          </a:ln>
-        </p:spPr>
-        <p:txBody>
-          <a:bodyPr xmlns:a="http://schemas.openxmlformats.org/drawingml/2006/main" lIns="0" tIns="0" rIns="0" bIns="0" anchor="t">
-            <a:normAutofit fontScale="100000"/>
-          </a:bodyPr>
-          <a:lstStyle xmlns:a="http://schemas.openxmlformats.org/drawingml/2006/main"/>
-          <a:p xmlns:a="http://schemas.openxmlformats.org/drawingml/2006/main">
-            <a:pPr algn="r">
-              <a:buNone/>
-              <a:defRPr sz="1050" b="1">
-                <a:solidFill>
-                  <a:srgbClr val="5C6577"/>
-                </a:solidFill>
-                <a:latin typeface="Menlo"/>
-                <a:ea typeface="Menlo"/>
-                <a:cs typeface="Menlo"/>
-              </a:defRPr>
-            </a:pPr>
-            <a:r>
-              <a:rPr sz="1050" b="1">
-                <a:solidFill>
-                  <a:srgbClr val="5C6577"/>
-                </a:solidFill>
-                <a:latin typeface="Menlo"/>
-                <a:ea typeface="Menlo"/>
-                <a:cs typeface="Menlo"/>
-              </a:rPr>
-              <a:t>10</a:t>
-            </a:r>
-          </a:p>
-        </p:txBody>
-      </p:sp>
-      <p:sp>
-        <p:nvSpPr>
-          <p:cNvPr id="5" name="">
-            <a:extLst xmlns:a="http://schemas.openxmlformats.org/drawingml/2006/main">
-              <a:ext uri="{FF2B5EF4-FFF2-40B4-BE49-F238E27FC236}">
-                <a16:creationId xmlns:a16="http://schemas.microsoft.com/office/drawing/2014/main" id="{055F31EA-4A3C-4E48-8727-DD420EA71634}"/>
-              </a:ext>
-            </a:extLst>
-          </p:cNvPr>
-          <p:cNvSpPr>
-            <a:spLocks xmlns:a="http://schemas.openxmlformats.org/drawingml/2006/main" noGrp="1"/>
-          </p:cNvSpPr>
-          <p:nvPr/>
-        </p:nvSpPr>
-        <p:spPr>
-          <a:xfrm xmlns:a="http://schemas.openxmlformats.org/drawingml/2006/main">
-            <a:off x="552450" y="2076450"/>
-            <a:ext cx="914400" cy="323850"/>
-          </a:xfrm>
-          <a:prstGeom xmlns:a="http://schemas.openxmlformats.org/drawingml/2006/main" prst="roundRect">
-            <a:avLst>
-              <a:gd name="adj" fmla="val 50000"/>
-            </a:avLst>
-          </a:prstGeom>
-          <a:solidFill xmlns:a="http://schemas.openxmlformats.org/drawingml/2006/main">
-            <a:srgbClr val="F4A261"/>
-          </a:solidFill>
-          <a:ln xmlns:a="http://schemas.openxmlformats.org/drawingml/2006/main" w="9525">
-            <a:solidFill>
-              <a:srgbClr val="F4A261"/>
-            </a:solidFill>
-            <a:prstDash val="solid"/>
-          </a:ln>
-        </p:spPr>
-        <p:txBody>
-          <a:bodyPr xmlns:a="http://schemas.openxmlformats.org/drawingml/2006/main" lIns="76200" tIns="0" rIns="76200" bIns="0" anchor="ctr">
-            <a:normAutofit fontScale="100000"/>
-          </a:bodyPr>
-          <a:lstStyle xmlns:a="http://schemas.openxmlformats.org/drawingml/2006/main"/>
-          <a:p xmlns:a="http://schemas.openxmlformats.org/drawingml/2006/main">
-            <a:pPr algn="ctr">
-              <a:buNone/>
-              <a:defRPr sz="1050" b="1">
-                <a:solidFill>
-                  <a:srgbClr val="14213D"/>
-                </a:solidFill>
-                <a:latin typeface="Avenir Next"/>
-                <a:ea typeface="Avenir Next"/>
-                <a:cs typeface="Avenir Next"/>
-              </a:defRPr>
-            </a:pPr>
-            <a:r>
-              <a:rPr sz="1050" b="1">
-                <a:solidFill>
-                  <a:srgbClr val="14213D"/>
-                </a:solidFill>
-                <a:latin typeface="Avenir Next"/>
-                <a:ea typeface="Avenir Next"/>
-                <a:cs typeface="Avenir Next"/>
-              </a:rPr>
-              <a:t>LAB 1</a:t>
-            </a:r>
-          </a:p>
-        </p:txBody>
-      </p:sp>
-      <p:sp>
-        <p:nvSpPr>
-          <p:cNvPr id="6" name="">
-            <a:extLst xmlns:a="http://schemas.openxmlformats.org/drawingml/2006/main">
-              <a:ext uri="{FF2B5EF4-FFF2-40B4-BE49-F238E27FC236}">
-                <a16:creationId xmlns:a16="http://schemas.microsoft.com/office/drawing/2014/main" id="{72F06CF3-65DB-43EE-B18E-C291B27672FC}"/>
-              </a:ext>
-            </a:extLst>
-          </p:cNvPr>
-          <p:cNvSpPr>
-            <a:spLocks xmlns:a="http://schemas.openxmlformats.org/drawingml/2006/main" noGrp="1"/>
-          </p:cNvSpPr>
-          <p:nvPr/>
-        </p:nvSpPr>
-        <p:spPr>
-          <a:xfrm xmlns:a="http://schemas.openxmlformats.org/drawingml/2006/main">
-            <a:off x="552450" y="2628900"/>
-            <a:ext cx="6096000" cy="619125"/>
-          </a:xfrm>
-          <a:prstGeom xmlns:a="http://schemas.openxmlformats.org/drawingml/2006/main" prst="rect">
-            <a:avLst/>
-          </a:prstGeom>
-          <a:noFill xmlns:a="http://schemas.openxmlformats.org/drawingml/2006/main"/>
-          <a:ln xmlns:a="http://schemas.openxmlformats.org/drawingml/2006/main" w="0">
-            <a:noFill/>
-            <a:prstDash val="solid"/>
-          </a:ln>
-        </p:spPr>
-        <p:txBody>
-          <a:bodyPr xmlns:a="http://schemas.openxmlformats.org/drawingml/2006/main" lIns="0" tIns="0" rIns="0" bIns="0" anchor="t">
-            <a:normAutofit fontScale="87366"/>
-          </a:bodyPr>
-          <a:lstStyle xmlns:a="http://schemas.openxmlformats.org/drawingml/2006/main"/>
-          <a:p xmlns:a="http://schemas.openxmlformats.org/drawingml/2006/main">
-            <a:pPr>
-              <a:buNone/>
-              <a:defRPr sz="2325" b="1">
-                <a:solidFill>
-                  <a:srgbClr val="14213D"/>
-                </a:solidFill>
-                <a:latin typeface="Georgia"/>
-                <a:ea typeface="Georgia"/>
-                <a:cs typeface="Georgia"/>
-              </a:defRPr>
-            </a:pPr>
-            <a:r>
-              <a:rPr sz="2325" b="1">
-                <a:solidFill>
-                  <a:srgbClr val="14213D"/>
-                </a:solidFill>
-                <a:latin typeface="Georgia"/>
-                <a:ea typeface="Georgia"/>
-                <a:cs typeface="Georgia"/>
-              </a:rPr>
-              <a:t>Choose a music service, store, game, or public service.</a:t>
-            </a:r>
-          </a:p>
-        </p:txBody>
-      </p:sp>
-      <p:sp>
-        <p:nvSpPr>
-          <p:cNvPr id="7" name="">
-            <a:extLst xmlns:a="http://schemas.openxmlformats.org/drawingml/2006/main">
-              <a:ext uri="{FF2B5EF4-FFF2-40B4-BE49-F238E27FC236}">
-                <a16:creationId xmlns:a16="http://schemas.microsoft.com/office/drawing/2014/main" id="{930EE4E3-585B-4169-B2D2-FA7A1C58B93E}"/>
-              </a:ext>
-            </a:extLst>
-          </p:cNvPr>
-          <p:cNvSpPr>
-            <a:spLocks xmlns:a="http://schemas.openxmlformats.org/drawingml/2006/main" noGrp="1"/>
-          </p:cNvSpPr>
-          <p:nvPr/>
-        </p:nvSpPr>
-        <p:spPr>
-          <a:xfrm xmlns:a="http://schemas.openxmlformats.org/drawingml/2006/main">
-            <a:off x="7067550" y="1924050"/>
-            <a:ext cx="361950" cy="323850"/>
-          </a:xfrm>
-          <a:prstGeom xmlns:a="http://schemas.openxmlformats.org/drawingml/2006/main" prst="roundRect">
-            <a:avLst>
-              <a:gd name="adj" fmla="val 50000"/>
-            </a:avLst>
-          </a:prstGeom>
-          <a:solidFill xmlns:a="http://schemas.openxmlformats.org/drawingml/2006/main">
-            <a:srgbClr val="0B5FFF"/>
-          </a:solidFill>
-          <a:ln xmlns:a="http://schemas.openxmlformats.org/drawingml/2006/main" w="9525">
-            <a:solidFill>
-              <a:srgbClr val="0B5FFF"/>
-            </a:solidFill>
-            <a:prstDash val="solid"/>
-          </a:ln>
-        </p:spPr>
-        <p:txBody>
-          <a:bodyPr xmlns:a="http://schemas.openxmlformats.org/drawingml/2006/main" lIns="76200" tIns="0" rIns="76200" bIns="0" anchor="ctr">
-            <a:normAutofit fontScale="100000"/>
-          </a:bodyPr>
-          <a:lstStyle xmlns:a="http://schemas.openxmlformats.org/drawingml/2006/main"/>
-          <a:p xmlns:a="http://schemas.openxmlformats.org/drawingml/2006/main">
-            <a:pPr algn="ctr">
-              <a:buNone/>
-              <a:defRPr sz="1050" b="1">
-                <a:solidFill>
-                  <a:srgbClr val="FFFFFF"/>
-                </a:solidFill>
-                <a:latin typeface="Avenir Next"/>
-                <a:ea typeface="Avenir Next"/>
-                <a:cs typeface="Avenir Next"/>
-              </a:defRPr>
-            </a:pPr>
-            <a:r>
-              <a:rPr sz="1050" b="1">
-                <a:solidFill>
-                  <a:srgbClr val="FFFFFF"/>
-                </a:solidFill>
-                <a:latin typeface="Avenir Next"/>
-                <a:ea typeface="Avenir Next"/>
-                <a:cs typeface="Avenir Next"/>
-              </a:rPr>
-              <a:t>1</a:t>
-            </a:r>
-          </a:p>
-        </p:txBody>
-      </p:sp>
-      <p:sp>
-        <p:nvSpPr>
-          <p:cNvPr id="8" name="">
-            <a:extLst xmlns:a="http://schemas.openxmlformats.org/drawingml/2006/main">
-              <a:ext uri="{FF2B5EF4-FFF2-40B4-BE49-F238E27FC236}">
-                <a16:creationId xmlns:a16="http://schemas.microsoft.com/office/drawing/2014/main" id="{50620410-3D6D-4D59-8722-8E7E13BB1D4A}"/>
-              </a:ext>
-            </a:extLst>
-          </p:cNvPr>
-          <p:cNvSpPr>
-            <a:spLocks xmlns:a="http://schemas.openxmlformats.org/drawingml/2006/main" noGrp="1"/>
-          </p:cNvSpPr>
-          <p:nvPr/>
-        </p:nvSpPr>
-        <p:spPr>
-          <a:xfrm xmlns:a="http://schemas.openxmlformats.org/drawingml/2006/main">
-            <a:off x="7648575" y="1914525"/>
-            <a:ext cx="3714750" cy="285750"/>
-          </a:xfrm>
-          <a:prstGeom xmlns:a="http://schemas.openxmlformats.org/drawingml/2006/main" prst="rect">
-            <a:avLst/>
-          </a:prstGeom>
-          <a:noFill xmlns:a="http://schemas.openxmlformats.org/drawingml/2006/main"/>
-          <a:ln xmlns:a="http://schemas.openxmlformats.org/drawingml/2006/main" w="0">
-            <a:noFill/>
-            <a:prstDash val="solid"/>
-          </a:ln>
-        </p:spPr>
-        <p:txBody>
-          <a:bodyPr xmlns:a="http://schemas.openxmlformats.org/drawingml/2006/main" lIns="0" tIns="0" rIns="0" bIns="0" anchor="t">
-            <a:normAutofit fontScale="100000"/>
-          </a:bodyPr>
-          <a:lstStyle xmlns:a="http://schemas.openxmlformats.org/drawingml/2006/main"/>
-          <a:p xmlns:a="http://schemas.openxmlformats.org/drawingml/2006/main">
-            <a:pPr>
-              <a:buNone/>
-              <a:defRPr sz="1575" b="1">
-                <a:solidFill>
-                  <a:srgbClr val="14213D"/>
-                </a:solidFill>
-                <a:latin typeface="Avenir Next"/>
-                <a:ea typeface="Avenir Next"/>
-                <a:cs typeface="Avenir Next"/>
-              </a:defRPr>
-            </a:pPr>
-            <a:r>
-              <a:rPr sz="1575" b="1">
-                <a:solidFill>
-                  <a:srgbClr val="14213D"/>
-                </a:solidFill>
-                <a:latin typeface="Avenir Next"/>
-                <a:ea typeface="Avenir Next"/>
-                <a:cs typeface="Avenir Next"/>
-              </a:rPr>
-              <a:t>Name the important data</a:t>
-            </a:r>
-          </a:p>
-        </p:txBody>
-      </p:sp>
-      <p:sp>
-        <p:nvSpPr>
-          <p:cNvPr id="9" name="">
-            <a:extLst xmlns:a="http://schemas.openxmlformats.org/drawingml/2006/main">
-              <a:ext uri="{FF2B5EF4-FFF2-40B4-BE49-F238E27FC236}">
-                <a16:creationId xmlns:a16="http://schemas.microsoft.com/office/drawing/2014/main" id="{9369982A-E08B-4EFC-8D66-69E036CE5308}"/>
-              </a:ext>
-            </a:extLst>
-          </p:cNvPr>
-          <p:cNvSpPr>
-            <a:spLocks xmlns:a="http://schemas.openxmlformats.org/drawingml/2006/main" noGrp="1"/>
-          </p:cNvSpPr>
-          <p:nvPr/>
-        </p:nvSpPr>
-        <p:spPr>
-          <a:xfrm xmlns:a="http://schemas.openxmlformats.org/drawingml/2006/main">
-            <a:off x="7648575" y="2247900"/>
-            <a:ext cx="3714750" cy="476250"/>
-          </a:xfrm>
-          <a:prstGeom xmlns:a="http://schemas.openxmlformats.org/drawingml/2006/main" prst="rect">
-            <a:avLst/>
-          </a:prstGeom>
-          <a:noFill xmlns:a="http://schemas.openxmlformats.org/drawingml/2006/main"/>
-          <a:ln xmlns:a="http://schemas.openxmlformats.org/drawingml/2006/main" w="0">
-            <a:noFill/>
-            <a:prstDash val="solid"/>
-          </a:ln>
-        </p:spPr>
-        <p:txBody>
-          <a:bodyPr xmlns:a="http://schemas.openxmlformats.org/drawingml/2006/main" lIns="0" tIns="0" rIns="0" bIns="0" anchor="t">
-            <a:normAutofit fontScale="100000"/>
-          </a:bodyPr>
-          <a:lstStyle xmlns:a="http://schemas.openxmlformats.org/drawingml/2006/main"/>
-          <a:p xmlns:a="http://schemas.openxmlformats.org/drawingml/2006/main">
-            <a:pPr>
-              <a:buNone/>
-              <a:defRPr sz="1275">
-                <a:solidFill>
-                  <a:srgbClr val="5C6577"/>
-                </a:solidFill>
-                <a:latin typeface="Avenir Next"/>
-                <a:ea typeface="Avenir Next"/>
-                <a:cs typeface="Avenir Next"/>
-              </a:defRPr>
-            </a:pPr>
-            <a:r>
-              <a:rPr sz="1275">
-                <a:solidFill>
-                  <a:srgbClr val="5C6577"/>
-                </a:solidFill>
-                <a:latin typeface="Avenir Next"/>
-                <a:ea typeface="Avenir Next"/>
-                <a:cs typeface="Avenir Next"/>
-              </a:rPr>
-              <a:t>List the entities or facts the application must remember.</a:t>
-            </a:r>
-          </a:p>
-        </p:txBody>
-      </p:sp>
-      <p:sp>
-        <p:nvSpPr>
-          <p:cNvPr id="10" name="">
-            <a:extLst xmlns:a="http://schemas.openxmlformats.org/drawingml/2006/main">
-              <a:ext uri="{FF2B5EF4-FFF2-40B4-BE49-F238E27FC236}">
-                <a16:creationId xmlns:a16="http://schemas.microsoft.com/office/drawing/2014/main" id="{174C1B33-A21F-40D7-94F0-3F129D254A2A}"/>
-              </a:ext>
-            </a:extLst>
-          </p:cNvPr>
-          <p:cNvSpPr>
-            <a:spLocks xmlns:a="http://schemas.openxmlformats.org/drawingml/2006/main" noGrp="1"/>
-          </p:cNvSpPr>
-          <p:nvPr/>
-        </p:nvSpPr>
-        <p:spPr>
-          <a:xfrm xmlns:a="http://schemas.openxmlformats.org/drawingml/2006/main">
-            <a:off x="7067550" y="2924175"/>
-            <a:ext cx="361950" cy="323850"/>
-          </a:xfrm>
-          <a:prstGeom xmlns:a="http://schemas.openxmlformats.org/drawingml/2006/main" prst="roundRect">
-            <a:avLst>
-              <a:gd name="adj" fmla="val 50000"/>
-            </a:avLst>
-          </a:prstGeom>
-          <a:solidFill xmlns:a="http://schemas.openxmlformats.org/drawingml/2006/main">
-            <a:srgbClr val="14213D"/>
-          </a:solidFill>
-          <a:ln xmlns:a="http://schemas.openxmlformats.org/drawingml/2006/main" w="9525">
-            <a:solidFill>
-              <a:srgbClr val="14213D"/>
-            </a:solidFill>
-            <a:prstDash val="solid"/>
-          </a:ln>
-        </p:spPr>
-        <p:txBody>
-          <a:bodyPr xmlns:a="http://schemas.openxmlformats.org/drawingml/2006/main" lIns="76200" tIns="0" rIns="76200" bIns="0" anchor="ctr">
-            <a:normAutofit fontScale="100000"/>
-          </a:bodyPr>
-          <a:lstStyle xmlns:a="http://schemas.openxmlformats.org/drawingml/2006/main"/>
-          <a:p xmlns:a="http://schemas.openxmlformats.org/drawingml/2006/main">
-            <a:pPr algn="ctr">
-              <a:buNone/>
-              <a:defRPr sz="1050" b="1">
-                <a:solidFill>
-                  <a:srgbClr val="FFFFFF"/>
-                </a:solidFill>
-                <a:latin typeface="Avenir Next"/>
-                <a:ea typeface="Avenir Next"/>
-                <a:cs typeface="Avenir Next"/>
-              </a:defRPr>
-            </a:pPr>
-            <a:r>
-              <a:rPr sz="1050" b="1">
-                <a:solidFill>
-                  <a:srgbClr val="FFFFFF"/>
-                </a:solidFill>
-                <a:latin typeface="Avenir Next"/>
-                <a:ea typeface="Avenir Next"/>
-                <a:cs typeface="Avenir Next"/>
-              </a:rPr>
-              <a:t>2</a:t>
-            </a:r>
-          </a:p>
-        </p:txBody>
-      </p:sp>
-      <p:sp>
-        <p:nvSpPr>
-          <p:cNvPr id="11" name="">
-            <a:extLst xmlns:a="http://schemas.openxmlformats.org/drawingml/2006/main">
-              <a:ext uri="{FF2B5EF4-FFF2-40B4-BE49-F238E27FC236}">
-                <a16:creationId xmlns:a16="http://schemas.microsoft.com/office/drawing/2014/main" id="{44F0BF52-FAC0-417E-AB38-6E23E2EB00D5}"/>
-              </a:ext>
-            </a:extLst>
-          </p:cNvPr>
-          <p:cNvSpPr>
-            <a:spLocks xmlns:a="http://schemas.openxmlformats.org/drawingml/2006/main" noGrp="1"/>
-          </p:cNvSpPr>
-          <p:nvPr/>
-        </p:nvSpPr>
-        <p:spPr>
-          <a:xfrm xmlns:a="http://schemas.openxmlformats.org/drawingml/2006/main">
-            <a:off x="7648575" y="2914650"/>
-            <a:ext cx="3714750" cy="285750"/>
-          </a:xfrm>
-          <a:prstGeom xmlns:a="http://schemas.openxmlformats.org/drawingml/2006/main" prst="rect">
-            <a:avLst/>
-          </a:prstGeom>
-          <a:noFill xmlns:a="http://schemas.openxmlformats.org/drawingml/2006/main"/>
-          <a:ln xmlns:a="http://schemas.openxmlformats.org/drawingml/2006/main" w="0">
-            <a:noFill/>
-            <a:prstDash val="solid"/>
-          </a:ln>
-        </p:spPr>
-        <p:txBody>
-          <a:bodyPr xmlns:a="http://schemas.openxmlformats.org/drawingml/2006/main" lIns="0" tIns="0" rIns="0" bIns="0" anchor="t">
-            <a:normAutofit fontScale="100000"/>
-          </a:bodyPr>
-          <a:lstStyle xmlns:a="http://schemas.openxmlformats.org/drawingml/2006/main"/>
-          <a:p xmlns:a="http://schemas.openxmlformats.org/drawingml/2006/main">
-            <a:pPr>
-              <a:buNone/>
-              <a:defRPr sz="1575" b="1">
-                <a:solidFill>
-                  <a:srgbClr val="14213D"/>
-                </a:solidFill>
-                <a:latin typeface="Avenir Next"/>
-                <a:ea typeface="Avenir Next"/>
-                <a:cs typeface="Avenir Next"/>
-              </a:defRPr>
-            </a:pPr>
-            <a:r>
-              <a:rPr sz="1575" b="1">
-                <a:solidFill>
-                  <a:srgbClr val="14213D"/>
-                </a:solidFill>
-                <a:latin typeface="Avenir Next"/>
-                <a:ea typeface="Avenir Next"/>
-                <a:cs typeface="Avenir Next"/>
-              </a:rPr>
-              <a:t>Name the important questions</a:t>
-            </a:r>
-          </a:p>
-        </p:txBody>
-      </p:sp>
-      <p:sp>
-        <p:nvSpPr>
-          <p:cNvPr id="12" name="">
-            <a:extLst xmlns:a="http://schemas.openxmlformats.org/drawingml/2006/main">
-              <a:ext uri="{FF2B5EF4-FFF2-40B4-BE49-F238E27FC236}">
-                <a16:creationId xmlns:a16="http://schemas.microsoft.com/office/drawing/2014/main" id="{E3D4421D-B727-422B-BAC3-A4520E8EF5EB}"/>
-              </a:ext>
-            </a:extLst>
-          </p:cNvPr>
-          <p:cNvSpPr>
-            <a:spLocks xmlns:a="http://schemas.openxmlformats.org/drawingml/2006/main" noGrp="1"/>
-          </p:cNvSpPr>
-          <p:nvPr/>
-        </p:nvSpPr>
-        <p:spPr>
-          <a:xfrm xmlns:a="http://schemas.openxmlformats.org/drawingml/2006/main">
-            <a:off x="7648575" y="3248025"/>
-            <a:ext cx="3714750" cy="476250"/>
-          </a:xfrm>
-          <a:prstGeom xmlns:a="http://schemas.openxmlformats.org/drawingml/2006/main" prst="rect">
-            <a:avLst/>
-          </a:prstGeom>
-          <a:noFill xmlns:a="http://schemas.openxmlformats.org/drawingml/2006/main"/>
-          <a:ln xmlns:a="http://schemas.openxmlformats.org/drawingml/2006/main" w="0">
-            <a:noFill/>
-            <a:prstDash val="solid"/>
-          </a:ln>
-        </p:spPr>
-        <p:txBody>
-          <a:bodyPr xmlns:a="http://schemas.openxmlformats.org/drawingml/2006/main" lIns="0" tIns="0" rIns="0" bIns="0" anchor="t">
-            <a:normAutofit fontScale="100000"/>
-          </a:bodyPr>
-          <a:lstStyle xmlns:a="http://schemas.openxmlformats.org/drawingml/2006/main"/>
-          <a:p xmlns:a="http://schemas.openxmlformats.org/drawingml/2006/main">
-            <a:pPr>
-              <a:buNone/>
-              <a:defRPr sz="1275">
-                <a:solidFill>
-                  <a:srgbClr val="5C6577"/>
-                </a:solidFill>
-                <a:latin typeface="Avenir Next"/>
-                <a:ea typeface="Avenir Next"/>
-                <a:cs typeface="Avenir Next"/>
-              </a:defRPr>
-            </a:pPr>
-            <a:r>
-              <a:rPr sz="1275">
-                <a:solidFill>
-                  <a:srgbClr val="5C6577"/>
-                </a:solidFill>
-                <a:latin typeface="Avenir Next"/>
-                <a:ea typeface="Avenir Next"/>
-                <a:cs typeface="Avenir Next"/>
-              </a:rPr>
-              <a:t>Write three questions the application must answer.</a:t>
-            </a:r>
-          </a:p>
-        </p:txBody>
-      </p:sp>
-      <p:sp>
-        <p:nvSpPr>
-          <p:cNvPr id="13" name="">
-            <a:extLst xmlns:a="http://schemas.openxmlformats.org/drawingml/2006/main">
-              <a:ext uri="{FF2B5EF4-FFF2-40B4-BE49-F238E27FC236}">
-                <a16:creationId xmlns:a16="http://schemas.microsoft.com/office/drawing/2014/main" id="{4574DD5D-A16B-4A57-AA81-12278767C246}"/>
-              </a:ext>
-            </a:extLst>
-          </p:cNvPr>
-          <p:cNvSpPr>
-            <a:spLocks xmlns:a="http://schemas.openxmlformats.org/drawingml/2006/main" noGrp="1"/>
-          </p:cNvSpPr>
-          <p:nvPr/>
-        </p:nvSpPr>
-        <p:spPr>
-          <a:xfrm xmlns:a="http://schemas.openxmlformats.org/drawingml/2006/main">
-            <a:off x="7067550" y="3924300"/>
-            <a:ext cx="361950" cy="323850"/>
-          </a:xfrm>
-          <a:prstGeom xmlns:a="http://schemas.openxmlformats.org/drawingml/2006/main" prst="roundRect">
-            <a:avLst>
-              <a:gd name="adj" fmla="val 50000"/>
-            </a:avLst>
-          </a:prstGeom>
-          <a:solidFill xmlns:a="http://schemas.openxmlformats.org/drawingml/2006/main">
-            <a:srgbClr val="14213D"/>
-          </a:solidFill>
-          <a:ln xmlns:a="http://schemas.openxmlformats.org/drawingml/2006/main" w="9525">
-            <a:solidFill>
-              <a:srgbClr val="14213D"/>
-            </a:solidFill>
-            <a:prstDash val="solid"/>
-          </a:ln>
-        </p:spPr>
-        <p:txBody>
-          <a:bodyPr xmlns:a="http://schemas.openxmlformats.org/drawingml/2006/main" lIns="76200" tIns="0" rIns="76200" bIns="0" anchor="ctr">
-            <a:normAutofit fontScale="100000"/>
-          </a:bodyPr>
-          <a:lstStyle xmlns:a="http://schemas.openxmlformats.org/drawingml/2006/main"/>
-          <a:p xmlns:a="http://schemas.openxmlformats.org/drawingml/2006/main">
-            <a:pPr algn="ctr">
-              <a:buNone/>
-              <a:defRPr sz="1050" b="1">
-                <a:solidFill>
-                  <a:srgbClr val="FFFFFF"/>
-                </a:solidFill>
-                <a:latin typeface="Avenir Next"/>
-                <a:ea typeface="Avenir Next"/>
-                <a:cs typeface="Avenir Next"/>
-              </a:defRPr>
-            </a:pPr>
-            <a:r>
-              <a:rPr sz="1050" b="1">
-                <a:solidFill>
-                  <a:srgbClr val="FFFFFF"/>
-                </a:solidFill>
-                <a:latin typeface="Avenir Next"/>
-                <a:ea typeface="Avenir Next"/>
-                <a:cs typeface="Avenir Next"/>
-              </a:rPr>
-              <a:t>3</a:t>
-            </a:r>
-          </a:p>
-        </p:txBody>
-      </p:sp>
-      <p:sp>
-        <p:nvSpPr>
-          <p:cNvPr id="14" name="">
-            <a:extLst xmlns:a="http://schemas.openxmlformats.org/drawingml/2006/main">
-              <a:ext uri="{FF2B5EF4-FFF2-40B4-BE49-F238E27FC236}">
-                <a16:creationId xmlns:a16="http://schemas.microsoft.com/office/drawing/2014/main" id="{8B24D819-5B29-4FCE-AA2C-41F09DF97598}"/>
-              </a:ext>
-            </a:extLst>
-          </p:cNvPr>
-          <p:cNvSpPr>
-            <a:spLocks xmlns:a="http://schemas.openxmlformats.org/drawingml/2006/main" noGrp="1"/>
-          </p:cNvSpPr>
-          <p:nvPr/>
-        </p:nvSpPr>
-        <p:spPr>
-          <a:xfrm xmlns:a="http://schemas.openxmlformats.org/drawingml/2006/main">
-            <a:off x="7648575" y="3914775"/>
-            <a:ext cx="3714750" cy="285750"/>
-          </a:xfrm>
-          <a:prstGeom xmlns:a="http://schemas.openxmlformats.org/drawingml/2006/main" prst="rect">
-            <a:avLst/>
-          </a:prstGeom>
-          <a:noFill xmlns:a="http://schemas.openxmlformats.org/drawingml/2006/main"/>
-          <a:ln xmlns:a="http://schemas.openxmlformats.org/drawingml/2006/main" w="0">
-            <a:noFill/>
-            <a:prstDash val="solid"/>
-          </a:ln>
-        </p:spPr>
-        <p:txBody>
-          <a:bodyPr xmlns:a="http://schemas.openxmlformats.org/drawingml/2006/main" lIns="0" tIns="0" rIns="0" bIns="0" anchor="t">
-            <a:normAutofit fontScale="100000"/>
-          </a:bodyPr>
-          <a:lstStyle xmlns:a="http://schemas.openxmlformats.org/drawingml/2006/main"/>
-          <a:p xmlns:a="http://schemas.openxmlformats.org/drawingml/2006/main">
-            <a:pPr>
-              <a:buNone/>
-              <a:defRPr sz="1575" b="1">
-                <a:solidFill>
-                  <a:srgbClr val="14213D"/>
-                </a:solidFill>
-                <a:latin typeface="Avenir Next"/>
-                <a:ea typeface="Avenir Next"/>
-                <a:cs typeface="Avenir Next"/>
-              </a:defRPr>
-            </a:pPr>
-            <a:r>
-              <a:rPr sz="1575" b="1">
-                <a:solidFill>
-                  <a:srgbClr val="14213D"/>
-                </a:solidFill>
-                <a:latin typeface="Avenir Next"/>
-                <a:ea typeface="Avenir Next"/>
-                <a:cs typeface="Avenir Next"/>
-              </a:rPr>
-              <a:t>Trace one request</a:t>
-            </a:r>
-          </a:p>
-        </p:txBody>
-      </p:sp>
-      <p:sp>
-        <p:nvSpPr>
-          <p:cNvPr id="15" name="">
-            <a:extLst xmlns:a="http://schemas.openxmlformats.org/drawingml/2006/main">
-              <a:ext uri="{FF2B5EF4-FFF2-40B4-BE49-F238E27FC236}">
-                <a16:creationId xmlns:a16="http://schemas.microsoft.com/office/drawing/2014/main" id="{86BD929E-7DFD-4EED-993E-88D1CA809DB8}"/>
-              </a:ext>
-            </a:extLst>
-          </p:cNvPr>
-          <p:cNvSpPr>
-            <a:spLocks xmlns:a="http://schemas.openxmlformats.org/drawingml/2006/main" noGrp="1"/>
-          </p:cNvSpPr>
-          <p:nvPr/>
-        </p:nvSpPr>
-        <p:spPr>
-          <a:xfrm xmlns:a="http://schemas.openxmlformats.org/drawingml/2006/main">
-            <a:off x="7648575" y="4248150"/>
-            <a:ext cx="3714750" cy="476250"/>
-          </a:xfrm>
-          <a:prstGeom xmlns:a="http://schemas.openxmlformats.org/drawingml/2006/main" prst="rect">
-            <a:avLst/>
-          </a:prstGeom>
-          <a:noFill xmlns:a="http://schemas.openxmlformats.org/drawingml/2006/main"/>
-          <a:ln xmlns:a="http://schemas.openxmlformats.org/drawingml/2006/main" w="0">
-            <a:noFill/>
-            <a:prstDash val="solid"/>
-          </a:ln>
-        </p:spPr>
-        <p:txBody>
-          <a:bodyPr xmlns:a="http://schemas.openxmlformats.org/drawingml/2006/main" lIns="0" tIns="0" rIns="0" bIns="0" anchor="t">
-            <a:normAutofit fontScale="100000"/>
-          </a:bodyPr>
-          <a:lstStyle xmlns:a="http://schemas.openxmlformats.org/drawingml/2006/main"/>
-          <a:p xmlns:a="http://schemas.openxmlformats.org/drawingml/2006/main">
-            <a:pPr>
-              <a:buNone/>
-              <a:defRPr sz="1275">
-                <a:solidFill>
-                  <a:srgbClr val="5C6577"/>
-                </a:solidFill>
-                <a:latin typeface="Avenir Next"/>
-                <a:ea typeface="Avenir Next"/>
-                <a:cs typeface="Avenir Next"/>
-              </a:defRPr>
-            </a:pPr>
-            <a:r>
-              <a:rPr sz="1275">
-                <a:solidFill>
-                  <a:srgbClr val="5C6577"/>
-                </a:solidFill>
-                <a:latin typeface="Avenir Next"/>
-                <a:ea typeface="Avenir Next"/>
-                <a:cs typeface="Avenir Next"/>
-              </a:rPr>
-              <a:t>Describe the client → API → identity → DBMS → data path.</a:t>
-            </a:r>
-          </a:p>
-        </p:txBody>
-      </p:sp>
-      <p:sp>
-        <p:nvSpPr>
-          <p:cNvPr id="16" name="">
-            <a:extLst xmlns:a="http://schemas.openxmlformats.org/drawingml/2006/main">
-              <a:ext uri="{FF2B5EF4-FFF2-40B4-BE49-F238E27FC236}">
-                <a16:creationId xmlns:a16="http://schemas.microsoft.com/office/drawing/2014/main" id="{3AC42973-9A6F-4BB7-A064-A7CBE4AEC079}"/>
-              </a:ext>
-            </a:extLst>
-          </p:cNvPr>
-          <p:cNvSpPr>
-            <a:spLocks xmlns:a="http://schemas.openxmlformats.org/drawingml/2006/main" noGrp="1"/>
-          </p:cNvSpPr>
-          <p:nvPr/>
-        </p:nvSpPr>
-        <p:spPr>
-          <a:xfrm xmlns:a="http://schemas.openxmlformats.org/drawingml/2006/main">
-            <a:off x="7067550" y="4924425"/>
-            <a:ext cx="361950" cy="323850"/>
-          </a:xfrm>
-          <a:prstGeom xmlns:a="http://schemas.openxmlformats.org/drawingml/2006/main" prst="roundRect">
-            <a:avLst>
-              <a:gd name="adj" fmla="val 50000"/>
-            </a:avLst>
-          </a:prstGeom>
-          <a:solidFill xmlns:a="http://schemas.openxmlformats.org/drawingml/2006/main">
-            <a:srgbClr val="14213D"/>
-          </a:solidFill>
-          <a:ln xmlns:a="http://schemas.openxmlformats.org/drawingml/2006/main" w="9525">
-            <a:solidFill>
-              <a:srgbClr val="14213D"/>
-            </a:solidFill>
-            <a:prstDash val="solid"/>
-          </a:ln>
-        </p:spPr>
-        <p:txBody>
-          <a:bodyPr xmlns:a="http://schemas.openxmlformats.org/drawingml/2006/main" lIns="76200" tIns="0" rIns="76200" bIns="0" anchor="ctr">
-            <a:normAutofit fontScale="100000"/>
-          </a:bodyPr>
-          <a:lstStyle xmlns:a="http://schemas.openxmlformats.org/drawingml/2006/main"/>
-          <a:p xmlns:a="http://schemas.openxmlformats.org/drawingml/2006/main">
-            <a:pPr algn="ctr">
-              <a:buNone/>
-              <a:defRPr sz="1050" b="1">
-                <a:solidFill>
-                  <a:srgbClr val="FFFFFF"/>
-                </a:solidFill>
-                <a:latin typeface="Avenir Next"/>
-                <a:ea typeface="Avenir Next"/>
-                <a:cs typeface="Avenir Next"/>
-              </a:defRPr>
-            </a:pPr>
-            <a:r>
-              <a:rPr sz="1050" b="1">
-                <a:solidFill>
-                  <a:srgbClr val="FFFFFF"/>
-                </a:solidFill>
-                <a:latin typeface="Avenir Next"/>
-                <a:ea typeface="Avenir Next"/>
-                <a:cs typeface="Avenir Next"/>
-              </a:rPr>
-              <a:t>4</a:t>
-            </a:r>
-          </a:p>
-        </p:txBody>
-      </p:sp>
-      <p:sp>
-        <p:nvSpPr>
-          <p:cNvPr id="17" name="">
-            <a:extLst xmlns:a="http://schemas.openxmlformats.org/drawingml/2006/main">
-              <a:ext uri="{FF2B5EF4-FFF2-40B4-BE49-F238E27FC236}">
-                <a16:creationId xmlns:a16="http://schemas.microsoft.com/office/drawing/2014/main" id="{44EE60F3-3C18-4939-9C39-BA30C8E3F71E}"/>
-              </a:ext>
-            </a:extLst>
-          </p:cNvPr>
-          <p:cNvSpPr>
-            <a:spLocks xmlns:a="http://schemas.openxmlformats.org/drawingml/2006/main" noGrp="1"/>
-          </p:cNvSpPr>
-          <p:nvPr/>
-        </p:nvSpPr>
-        <p:spPr>
-          <a:xfrm xmlns:a="http://schemas.openxmlformats.org/drawingml/2006/main">
-            <a:off x="7648575" y="4914900"/>
-            <a:ext cx="3714750" cy="285750"/>
-          </a:xfrm>
-          <a:prstGeom xmlns:a="http://schemas.openxmlformats.org/drawingml/2006/main" prst="rect">
-            <a:avLst/>
-          </a:prstGeom>
-          <a:noFill xmlns:a="http://schemas.openxmlformats.org/drawingml/2006/main"/>
-          <a:ln xmlns:a="http://schemas.openxmlformats.org/drawingml/2006/main" w="0">
-            <a:noFill/>
-            <a:prstDash val="solid"/>
-          </a:ln>
-        </p:spPr>
-        <p:txBody>
-          <a:bodyPr xmlns:a="http://schemas.openxmlformats.org/drawingml/2006/main" lIns="0" tIns="0" rIns="0" bIns="0" anchor="t">
-            <a:normAutofit fontScale="100000"/>
-          </a:bodyPr>
-          <a:lstStyle xmlns:a="http://schemas.openxmlformats.org/drawingml/2006/main"/>
-          <a:p xmlns:a="http://schemas.openxmlformats.org/drawingml/2006/main">
-            <a:pPr>
-              <a:buNone/>
-              <a:defRPr sz="1575" b="1">
-                <a:solidFill>
-                  <a:srgbClr val="14213D"/>
-                </a:solidFill>
-                <a:latin typeface="Avenir Next"/>
-                <a:ea typeface="Avenir Next"/>
-                <a:cs typeface="Avenir Next"/>
-              </a:defRPr>
-            </a:pPr>
-            <a:r>
-              <a:rPr sz="1575" b="1">
-                <a:solidFill>
-                  <a:srgbClr val="14213D"/>
-                </a:solidFill>
-                <a:latin typeface="Avenir Next"/>
-                <a:ea typeface="Avenir Next"/>
-                <a:cs typeface="Avenir Next"/>
-              </a:rPr>
-              <a:t>Sketch two data shapes</a:t>
-            </a:r>
-          </a:p>
-        </p:txBody>
-      </p:sp>
-      <p:sp>
-        <p:nvSpPr>
-          <p:cNvPr id="18" name="">
-            <a:extLst xmlns:a="http://schemas.openxmlformats.org/drawingml/2006/main">
-              <a:ext uri="{FF2B5EF4-FFF2-40B4-BE49-F238E27FC236}">
-                <a16:creationId xmlns:a16="http://schemas.microsoft.com/office/drawing/2014/main" id="{E25403CB-F631-4A9E-8055-359D02BB158B}"/>
-              </a:ext>
-            </a:extLst>
-          </p:cNvPr>
-          <p:cNvSpPr>
-            <a:spLocks xmlns:a="http://schemas.openxmlformats.org/drawingml/2006/main" noGrp="1"/>
-          </p:cNvSpPr>
-          <p:nvPr/>
-        </p:nvSpPr>
-        <p:spPr>
-          <a:xfrm xmlns:a="http://schemas.openxmlformats.org/drawingml/2006/main">
-            <a:off x="7648575" y="5248275"/>
-            <a:ext cx="3714750" cy="476250"/>
-          </a:xfrm>
-          <a:prstGeom xmlns:a="http://schemas.openxmlformats.org/drawingml/2006/main" prst="rect">
-            <a:avLst/>
-          </a:prstGeom>
-          <a:noFill xmlns:a="http://schemas.openxmlformats.org/drawingml/2006/main"/>
-          <a:ln xmlns:a="http://schemas.openxmlformats.org/drawingml/2006/main" w="0">
-            <a:noFill/>
-            <a:prstDash val="solid"/>
-          </a:ln>
-        </p:spPr>
-        <p:txBody>
-          <a:bodyPr xmlns:a="http://schemas.openxmlformats.org/drawingml/2006/main" lIns="0" tIns="0" rIns="0" bIns="0" anchor="t">
-            <a:normAutofit fontScale="100000"/>
-          </a:bodyPr>
-          <a:lstStyle xmlns:a="http://schemas.openxmlformats.org/drawingml/2006/main"/>
-          <a:p xmlns:a="http://schemas.openxmlformats.org/drawingml/2006/main">
-            <a:pPr>
-              <a:buNone/>
-              <a:defRPr sz="1275">
-                <a:solidFill>
-                  <a:srgbClr val="5C6577"/>
-                </a:solidFill>
-                <a:latin typeface="Avenir Next"/>
-                <a:ea typeface="Avenir Next"/>
-                <a:cs typeface="Avenir Next"/>
-              </a:defRPr>
-            </a:pPr>
-            <a:r>
-              <a:rPr sz="1275">
-                <a:solidFill>
-                  <a:srgbClr val="5C6577"/>
-                </a:solidFill>
-                <a:latin typeface="Avenir Next"/>
-                <a:ea typeface="Avenir Next"/>
-                <a:cs typeface="Avenir Next"/>
-              </a:rPr>
-              <a:t>Show one small table idea and one small JSON document idea.</a:t>
-            </a:r>
-          </a:p>
-        </p:txBody>
-      </p:sp>
-      <p:sp>
-        <p:nvSpPr>
-          <p:cNvPr id="19" name="code-block">
-            <a:extLst xmlns:a="http://schemas.openxmlformats.org/drawingml/2006/main">
-              <a:ext uri="{FF2B5EF4-FFF2-40B4-BE49-F238E27FC236}">
-                <a16:creationId xmlns:a16="http://schemas.microsoft.com/office/drawing/2014/main" id="{983FE80E-1020-440D-A71D-482C05DEAD08}"/>
-              </a:ext>
-            </a:extLst>
-          </p:cNvPr>
-          <p:cNvSpPr>
-            <a:spLocks xmlns:a="http://schemas.openxmlformats.org/drawingml/2006/main" noGrp="1"/>
-          </p:cNvSpPr>
-          <p:nvPr/>
-        </p:nvSpPr>
-        <p:spPr>
-          <a:xfrm xmlns:a="http://schemas.openxmlformats.org/drawingml/2006/main">
-            <a:off x="552450" y="3905250"/>
-            <a:ext cx="5476875" cy="1000125"/>
-          </a:xfrm>
-          <a:prstGeom xmlns:a="http://schemas.openxmlformats.org/drawingml/2006/main" prst="roundRect">
-            <a:avLst>
-              <a:gd name="adj" fmla="val 15238"/>
-            </a:avLst>
-          </a:prstGeom>
-          <a:solidFill xmlns:a="http://schemas.openxmlformats.org/drawingml/2006/main">
-            <a:srgbClr val="172033"/>
-          </a:solidFill>
-          <a:ln xmlns:a="http://schemas.openxmlformats.org/drawingml/2006/main" w="9525">
-            <a:solidFill>
-              <a:srgbClr val="2D3953"/>
-            </a:solidFill>
-            <a:prstDash val="solid"/>
-          </a:ln>
-        </p:spPr>
-      </p:sp>
-      <p:sp>
-        <p:nvSpPr>
-          <p:cNvPr id="20" name="">
-            <a:extLst xmlns:a="http://schemas.openxmlformats.org/drawingml/2006/main">
-              <a:ext uri="{FF2B5EF4-FFF2-40B4-BE49-F238E27FC236}">
-                <a16:creationId xmlns:a16="http://schemas.microsoft.com/office/drawing/2014/main" id="{20738AD2-BBED-46A4-B2A5-27CF7DFFD11E}"/>
-              </a:ext>
-            </a:extLst>
-          </p:cNvPr>
-          <p:cNvSpPr>
-            <a:spLocks xmlns:a="http://schemas.openxmlformats.org/drawingml/2006/main" noGrp="1"/>
-          </p:cNvSpPr>
-          <p:nvPr/>
-        </p:nvSpPr>
-        <p:spPr>
-          <a:xfrm xmlns:a="http://schemas.openxmlformats.org/drawingml/2006/main">
-            <a:off x="762000" y="4038600"/>
-            <a:ext cx="5057775" cy="266700"/>
-          </a:xfrm>
-          <a:prstGeom xmlns:a="http://schemas.openxmlformats.org/drawingml/2006/main" prst="rect">
-            <a:avLst/>
-          </a:prstGeom>
-          <a:noFill xmlns:a="http://schemas.openxmlformats.org/drawingml/2006/main"/>
-          <a:ln xmlns:a="http://schemas.openxmlformats.org/drawingml/2006/main" w="0">
-            <a:noFill/>
-            <a:prstDash val="solid"/>
-          </a:ln>
-        </p:spPr>
-        <p:txBody>
-          <a:bodyPr xmlns:a="http://schemas.openxmlformats.org/drawingml/2006/main" lIns="0" tIns="0" rIns="0" bIns="0" anchor="t">
-            <a:normAutofit fontScale="100000"/>
-          </a:bodyPr>
-          <a:lstStyle xmlns:a="http://schemas.openxmlformats.org/drawingml/2006/main"/>
-          <a:p xmlns:a="http://schemas.openxmlformats.org/drawingml/2006/main">
-            <a:pPr>
-              <a:buNone/>
-              <a:defRPr sz="1050" b="1">
-                <a:solidFill>
-                  <a:srgbClr val="F4A261"/>
-                </a:solidFill>
-                <a:latin typeface="Avenir Next"/>
-                <a:ea typeface="Avenir Next"/>
-                <a:cs typeface="Avenir Next"/>
-              </a:defRPr>
-            </a:pPr>
-            <a:r>
-              <a:rPr sz="1050" b="1">
-                <a:solidFill>
-                  <a:srgbClr val="F4A261"/>
-                </a:solidFill>
-                <a:latin typeface="Avenir Next"/>
-                <a:ea typeface="Avenir Next"/>
-                <a:cs typeface="Avenir Next"/>
-              </a:rPr>
-              <a:t>CREATE THIS FILE</a:t>
-            </a:r>
-          </a:p>
-        </p:txBody>
-      </p:sp>
-      <p:sp>
-        <p:nvSpPr>
-          <p:cNvPr id="21" name="">
-            <a:extLst xmlns:a="http://schemas.openxmlformats.org/drawingml/2006/main">
-              <a:ext uri="{FF2B5EF4-FFF2-40B4-BE49-F238E27FC236}">
-                <a16:creationId xmlns:a16="http://schemas.microsoft.com/office/drawing/2014/main" id="{CA75CB03-09D2-4C8B-BBDE-EFDD1FDF96CF}"/>
-              </a:ext>
-            </a:extLst>
-          </p:cNvPr>
-          <p:cNvSpPr>
-            <a:spLocks xmlns:a="http://schemas.openxmlformats.org/drawingml/2006/main" noGrp="1"/>
-          </p:cNvSpPr>
-          <p:nvPr/>
-        </p:nvSpPr>
-        <p:spPr>
-          <a:xfrm xmlns:a="http://schemas.openxmlformats.org/drawingml/2006/main">
-            <a:off x="762000" y="4381500"/>
-            <a:ext cx="5057775" cy="371475"/>
-          </a:xfrm>
-          <a:prstGeom xmlns:a="http://schemas.openxmlformats.org/drawingml/2006/main" prst="rect">
-            <a:avLst/>
-          </a:prstGeom>
-          <a:noFill xmlns:a="http://schemas.openxmlformats.org/drawingml/2006/main"/>
-          <a:ln xmlns:a="http://schemas.openxmlformats.org/drawingml/2006/main" w="0">
-            <a:noFill/>
-            <a:prstDash val="solid"/>
-          </a:ln>
-        </p:spPr>
-        <p:txBody>
-          <a:bodyPr xmlns:a="http://schemas.openxmlformats.org/drawingml/2006/main" lIns="0" tIns="0" rIns="0" bIns="0" anchor="t">
-            <a:normAutofit fontScale="100000"/>
-          </a:bodyPr>
-          <a:lstStyle xmlns:a="http://schemas.openxmlformats.org/drawingml/2006/main"/>
-          <a:p xmlns:a="http://schemas.openxmlformats.org/drawingml/2006/main">
-            <a:pPr>
-              <a:lnSpc>
-                <a:spcPct val="115000"/>
-              </a:lnSpc>
-              <a:buNone/>
-              <a:defRPr sz="1575">
-                <a:solidFill>
-                  <a:srgbClr val="F8FAFC"/>
-                </a:solidFill>
-                <a:latin typeface="Menlo"/>
-                <a:ea typeface="Menlo"/>
-                <a:cs typeface="Menlo"/>
-              </a:defRPr>
-            </a:pPr>
-            <a:r>
-              <a:rPr sz="1575">
-                <a:solidFill>
-                  <a:srgbClr val="F8FAFC"/>
-                </a:solidFill>
-                <a:latin typeface="Menlo"/>
-                <a:ea typeface="Menlo"/>
-                <a:cs typeface="Menlo"/>
-              </a:rPr>
-              <a:t>week_01/app_database_map.md</a:t>
-            </a:r>
-          </a:p>
-        </p:txBody>
-      </p:sp>
-      <p:sp>
-        <p:nvSpPr>
-          <p:cNvPr id="22" name="">
-            <a:extLst xmlns:a="http://schemas.openxmlformats.org/drawingml/2006/main">
-              <a:ext uri="{FF2B5EF4-FFF2-40B4-BE49-F238E27FC236}">
-                <a16:creationId xmlns:a16="http://schemas.microsoft.com/office/drawing/2014/main" id="{6B7D166B-85B7-4E5E-8F53-C9DC0D05CCEE}"/>
-              </a:ext>
-            </a:extLst>
-          </p:cNvPr>
-          <p:cNvSpPr>
-            <a:spLocks xmlns:a="http://schemas.openxmlformats.org/drawingml/2006/main" noGrp="1"/>
-          </p:cNvSpPr>
-          <p:nvPr/>
-        </p:nvSpPr>
-        <p:spPr>
-          <a:xfrm xmlns:a="http://schemas.openxmlformats.org/drawingml/2006/main">
-            <a:off x="552450" y="5229225"/>
-            <a:ext cx="5476875" cy="400050"/>
-          </a:xfrm>
-          <a:prstGeom xmlns:a="http://schemas.openxmlformats.org/drawingml/2006/main" prst="rect">
-            <a:avLst/>
-          </a:prstGeom>
-          <a:noFill xmlns:a="http://schemas.openxmlformats.org/drawingml/2006/main"/>
-          <a:ln xmlns:a="http://schemas.openxmlformats.org/drawingml/2006/main" w="0">
-            <a:noFill/>
-            <a:prstDash val="solid"/>
-          </a:ln>
-        </p:spPr>
-        <p:txBody>
-          <a:bodyPr xmlns:a="http://schemas.openxmlformats.org/drawingml/2006/main" lIns="0" tIns="0" rIns="0" bIns="0" anchor="t">
-            <a:normAutofit fontScale="100000"/>
-          </a:bodyPr>
-          <a:lstStyle xmlns:a="http://schemas.openxmlformats.org/drawingml/2006/main"/>
-          <a:p xmlns:a="http://schemas.openxmlformats.org/drawingml/2006/main">
-            <a:pPr>
-              <a:buNone/>
-              <a:defRPr sz="1575" b="1">
-                <a:solidFill>
-                  <a:srgbClr val="007C77"/>
-                </a:solidFill>
-                <a:latin typeface="Avenir Next"/>
-                <a:ea typeface="Avenir Next"/>
-                <a:cs typeface="Avenir Next"/>
-              </a:defRPr>
-            </a:pPr>
-            <a:r>
-              <a:rPr sz="1575" b="1">
-                <a:solidFill>
-                  <a:srgbClr val="007C77"/>
-                </a:solidFill>
-                <a:latin typeface="Avenir Next"/>
-                <a:ea typeface="Avenir Next"/>
-                <a:cs typeface="Avenir Next"/>
-              </a:rPr>
-              <a:t>Submit the GitHub URL for that file before leaving class.</a:t>
-            </a:r>
-          </a:p>
-        </p:txBody>
-      </p:sp>
-    </p:spTree>
-    <p:extLst>
-      <p:ext uri="{BB962C8B-B14F-4D97-AF65-F5344CB8AC3E}">
-        <p14:creationId xmlns:p14="http://schemas.microsoft.com/office/powerpoint/2010/main" val="801736138"/>
-      </p:ext>
-    </p:extLst>
-  </p:cSld>
-</p:sld>
-</file>
-
 <file path=ppt/slides/slide11.xml><?xml version="1.0" encoding="utf-8"?>
 <p:sld xmlns:p="http://schemas.openxmlformats.org/presentationml/2006/main">
   <p:cSld>
@@ -13081,1009 +11468,6 @@
 </p:sld>
 </file>
 
-<file path=ppt/slides/slide19.xml><?xml version="1.0" encoding="utf-8"?>
-<p:sld xmlns:p="http://schemas.openxmlformats.org/presentationml/2006/main">
-  <p:cSld>
-    <p:bg>
-      <p:bgPr>
-        <a:solidFill xmlns:a="http://schemas.openxmlformats.org/drawingml/2006/main">
-          <a:srgbClr val="F7F3EA"/>
-        </a:solidFill>
-      </p:bgPr>
-    </p:bg>
-    <p:spTree>
-      <p:nvGrpSpPr>
-        <p:cNvPr id="1" name=""/>
-        <p:cNvGrpSpPr/>
-        <p:nvPr/>
-      </p:nvGrpSpPr>
-      <p:grpSpPr>
-        <a:xfrm xmlns:a="http://schemas.openxmlformats.org/drawingml/2006/main"/>
-      </p:grpSpPr>
-      <p:sp>
-        <p:nvSpPr>
-          <p:cNvPr id="19" name="">
-            <a:extLst xmlns:a="http://schemas.openxmlformats.org/drawingml/2006/main">
-              <a:ext uri="{FF2B5EF4-FFF2-40B4-BE49-F238E27FC236}">
-                <a16:creationId xmlns:a16="http://schemas.microsoft.com/office/drawing/2014/main" id="{3F0104DD-09FA-48AC-B3CC-28B488A5F4C2}"/>
-              </a:ext>
-            </a:extLst>
-          </p:cNvPr>
-          <p:cNvSpPr>
-            <a:spLocks xmlns:a="http://schemas.openxmlformats.org/drawingml/2006/main" noGrp="1"/>
-          </p:cNvSpPr>
-          <p:nvPr/>
-        </p:nvSpPr>
-        <p:spPr>
-          <a:xfrm xmlns:a="http://schemas.openxmlformats.org/drawingml/2006/main">
-            <a:off x="552450" y="400050"/>
-            <a:ext cx="1447800" cy="323850"/>
-          </a:xfrm>
-          <a:prstGeom xmlns:a="http://schemas.openxmlformats.org/drawingml/2006/main" prst="roundRect">
-            <a:avLst>
-              <a:gd name="adj" fmla="val 50000"/>
-            </a:avLst>
-          </a:prstGeom>
-          <a:solidFill xmlns:a="http://schemas.openxmlformats.org/drawingml/2006/main">
-            <a:srgbClr val="14213D"/>
-          </a:solidFill>
-          <a:ln xmlns:a="http://schemas.openxmlformats.org/drawingml/2006/main" w="9525">
-            <a:solidFill>
-              <a:srgbClr val="14213D"/>
-            </a:solidFill>
-            <a:prstDash val="solid"/>
-          </a:ln>
-        </p:spPr>
-        <p:txBody>
-          <a:bodyPr xmlns:a="http://schemas.openxmlformats.org/drawingml/2006/main" lIns="76200" tIns="0" rIns="76200" bIns="0" anchor="ctr">
-            <a:normAutofit fontScale="100000"/>
-          </a:bodyPr>
-          <a:lstStyle xmlns:a="http://schemas.openxmlformats.org/drawingml/2006/main"/>
-          <a:p xmlns:a="http://schemas.openxmlformats.org/drawingml/2006/main">
-            <a:pPr algn="ctr">
-              <a:buNone/>
-              <a:defRPr sz="1050" b="1">
-                <a:solidFill>
-                  <a:srgbClr val="FFFFFF"/>
-                </a:solidFill>
-                <a:latin typeface="Avenir Next"/>
-                <a:ea typeface="Avenir Next"/>
-                <a:cs typeface="Avenir Next"/>
-              </a:defRPr>
-            </a:pPr>
-            <a:r>
-              <a:rPr sz="1050" b="1">
-                <a:solidFill>
-                  <a:srgbClr val="FFFFFF"/>
-                </a:solidFill>
-                <a:latin typeface="Avenir Next"/>
-                <a:ea typeface="Avenir Next"/>
-                <a:cs typeface="Avenir Next"/>
-              </a:rPr>
-              <a:t>IN-CLASS LAB</a:t>
-            </a:r>
-          </a:p>
-        </p:txBody>
-      </p:sp>
-      <p:sp>
-        <p:nvSpPr>
-          <p:cNvPr id="2" name="slide-title">
-            <a:extLst xmlns:a="http://schemas.openxmlformats.org/drawingml/2006/main">
-              <a:ext uri="{FF2B5EF4-FFF2-40B4-BE49-F238E27FC236}">
-                <a16:creationId xmlns:a16="http://schemas.microsoft.com/office/drawing/2014/main" id="{D96ABF50-C436-4937-8C87-F7780073ABB0}"/>
-              </a:ext>
-            </a:extLst>
-          </p:cNvPr>
-          <p:cNvSpPr>
-            <a:spLocks xmlns:a="http://schemas.openxmlformats.org/drawingml/2006/main" noGrp="1"/>
-          </p:cNvSpPr>
-          <p:nvPr/>
-        </p:nvSpPr>
-        <p:spPr>
-          <a:xfrm xmlns:a="http://schemas.openxmlformats.org/drawingml/2006/main">
-            <a:off x="552450" y="876300"/>
-            <a:ext cx="11087100" cy="704850"/>
-          </a:xfrm>
-          <a:prstGeom xmlns:a="http://schemas.openxmlformats.org/drawingml/2006/main" prst="rect">
-            <a:avLst/>
-          </a:prstGeom>
-          <a:noFill xmlns:a="http://schemas.openxmlformats.org/drawingml/2006/main"/>
-          <a:ln xmlns:a="http://schemas.openxmlformats.org/drawingml/2006/main" w="0">
-            <a:noFill/>
-            <a:prstDash val="solid"/>
-          </a:ln>
-        </p:spPr>
-        <p:txBody>
-          <a:bodyPr xmlns:a="http://schemas.openxmlformats.org/drawingml/2006/main" lIns="0" tIns="0" rIns="0" bIns="0" anchor="t">
-            <a:normAutofit fontScale="100000"/>
-          </a:bodyPr>
-          <a:lstStyle xmlns:a="http://schemas.openxmlformats.org/drawingml/2006/main"/>
-          <a:p xmlns:a="http://schemas.openxmlformats.org/drawingml/2006/main">
-            <a:pPr>
-              <a:lnSpc>
-                <a:spcPct val="95000"/>
-              </a:lnSpc>
-              <a:buNone/>
-              <a:defRPr sz="3000" b="1">
-                <a:solidFill>
-                  <a:srgbClr val="14213D"/>
-                </a:solidFill>
-                <a:latin typeface="Georgia"/>
-                <a:ea typeface="Georgia"/>
-                <a:cs typeface="Georgia"/>
-              </a:defRPr>
-            </a:pPr>
-            <a:r>
-              <a:rPr sz="3000" b="1">
-                <a:solidFill>
-                  <a:srgbClr val="14213D"/>
-                </a:solidFill>
-                <a:latin typeface="Georgia"/>
-                <a:ea typeface="Georgia"/>
-                <a:cs typeface="Georgia"/>
-              </a:rPr>
-              <a:t>Translate questions into relational operations and SQL</a:t>
-            </a:r>
-          </a:p>
-        </p:txBody>
-      </p:sp>
-      <p:sp>
-        <p:nvSpPr>
-          <p:cNvPr id="3" name="">
-            <a:extLst xmlns:a="http://schemas.openxmlformats.org/drawingml/2006/main">
-              <a:ext uri="{FF2B5EF4-FFF2-40B4-BE49-F238E27FC236}">
-                <a16:creationId xmlns:a16="http://schemas.microsoft.com/office/drawing/2014/main" id="{0CD0CD94-75DD-488F-AEC2-351C42A2207E}"/>
-              </a:ext>
-            </a:extLst>
-          </p:cNvPr>
-          <p:cNvSpPr>
-            <a:spLocks xmlns:a="http://schemas.openxmlformats.org/drawingml/2006/main" noGrp="1"/>
-          </p:cNvSpPr>
-          <p:nvPr/>
-        </p:nvSpPr>
-        <p:spPr>
-          <a:xfrm xmlns:a="http://schemas.openxmlformats.org/drawingml/2006/main">
-            <a:off x="571500" y="1562100"/>
-            <a:ext cx="10477500" cy="381000"/>
-          </a:xfrm>
-          <a:prstGeom xmlns:a="http://schemas.openxmlformats.org/drawingml/2006/main" prst="rect">
-            <a:avLst/>
-          </a:prstGeom>
-          <a:noFill xmlns:a="http://schemas.openxmlformats.org/drawingml/2006/main"/>
-          <a:ln xmlns:a="http://schemas.openxmlformats.org/drawingml/2006/main" w="0">
-            <a:noFill/>
-            <a:prstDash val="solid"/>
-          </a:ln>
-        </p:spPr>
-        <p:txBody>
-          <a:bodyPr xmlns:a="http://schemas.openxmlformats.org/drawingml/2006/main" lIns="0" tIns="0" rIns="0" bIns="0" anchor="t">
-            <a:normAutofit fontScale="100000"/>
-          </a:bodyPr>
-          <a:lstStyle xmlns:a="http://schemas.openxmlformats.org/drawingml/2006/main"/>
-          <a:p xmlns:a="http://schemas.openxmlformats.org/drawingml/2006/main">
-            <a:pPr>
-              <a:buNone/>
-              <a:defRPr sz="1425">
-                <a:solidFill>
-                  <a:srgbClr val="5C6577"/>
-                </a:solidFill>
-                <a:latin typeface="Avenir Next"/>
-                <a:ea typeface="Avenir Next"/>
-                <a:cs typeface="Avenir Next"/>
-              </a:defRPr>
-            </a:pPr>
-            <a:r>
-              <a:rPr sz="1425">
-                <a:solidFill>
-                  <a:srgbClr val="5C6577"/>
-                </a:solidFill>
-                <a:latin typeface="Avenir Next"/>
-                <a:ea typeface="Avenir Next"/>
-                <a:cs typeface="Avenir Next"/>
-              </a:rPr>
-              <a:t>Individual work. One Markdown file. No database connection is required.</a:t>
-            </a:r>
-          </a:p>
-        </p:txBody>
-      </p:sp>
-      <p:sp>
-        <p:nvSpPr>
-          <p:cNvPr id="4" name="">
-            <a:extLst xmlns:a="http://schemas.openxmlformats.org/drawingml/2006/main">
-              <a:ext uri="{FF2B5EF4-FFF2-40B4-BE49-F238E27FC236}">
-                <a16:creationId xmlns:a16="http://schemas.microsoft.com/office/drawing/2014/main" id="{71522E44-F108-4568-8F6F-3C3A88122388}"/>
-              </a:ext>
-            </a:extLst>
-          </p:cNvPr>
-          <p:cNvSpPr>
-            <a:spLocks xmlns:a="http://schemas.openxmlformats.org/drawingml/2006/main" noGrp="1"/>
-          </p:cNvSpPr>
-          <p:nvPr/>
-        </p:nvSpPr>
-        <p:spPr>
-          <a:xfrm xmlns:a="http://schemas.openxmlformats.org/drawingml/2006/main">
-            <a:off x="11144250" y="6334125"/>
-            <a:ext cx="495300" cy="228600"/>
-          </a:xfrm>
-          <a:prstGeom xmlns:a="http://schemas.openxmlformats.org/drawingml/2006/main" prst="rect">
-            <a:avLst/>
-          </a:prstGeom>
-          <a:noFill xmlns:a="http://schemas.openxmlformats.org/drawingml/2006/main"/>
-          <a:ln xmlns:a="http://schemas.openxmlformats.org/drawingml/2006/main" w="0">
-            <a:noFill/>
-            <a:prstDash val="solid"/>
-          </a:ln>
-        </p:spPr>
-        <p:txBody>
-          <a:bodyPr xmlns:a="http://schemas.openxmlformats.org/drawingml/2006/main" lIns="0" tIns="0" rIns="0" bIns="0" anchor="t">
-            <a:normAutofit fontScale="100000"/>
-          </a:bodyPr>
-          <a:lstStyle xmlns:a="http://schemas.openxmlformats.org/drawingml/2006/main"/>
-          <a:p xmlns:a="http://schemas.openxmlformats.org/drawingml/2006/main">
-            <a:pPr algn="r">
-              <a:buNone/>
-              <a:defRPr sz="1050" b="1">
-                <a:solidFill>
-                  <a:srgbClr val="5C6577"/>
-                </a:solidFill>
-                <a:latin typeface="Menlo"/>
-                <a:ea typeface="Menlo"/>
-                <a:cs typeface="Menlo"/>
-              </a:defRPr>
-            </a:pPr>
-            <a:r>
-              <a:rPr sz="1050" b="1">
-                <a:solidFill>
-                  <a:srgbClr val="5C6577"/>
-                </a:solidFill>
-                <a:latin typeface="Menlo"/>
-                <a:ea typeface="Menlo"/>
-                <a:cs typeface="Menlo"/>
-              </a:rPr>
-              <a:t>19</a:t>
-            </a:r>
-          </a:p>
-        </p:txBody>
-      </p:sp>
-      <p:sp>
-        <p:nvSpPr>
-          <p:cNvPr id="5" name="">
-            <a:extLst xmlns:a="http://schemas.openxmlformats.org/drawingml/2006/main">
-              <a:ext uri="{FF2B5EF4-FFF2-40B4-BE49-F238E27FC236}">
-                <a16:creationId xmlns:a16="http://schemas.microsoft.com/office/drawing/2014/main" id="{2E243679-F9D5-491A-A8C8-41C7A0FED28E}"/>
-              </a:ext>
-            </a:extLst>
-          </p:cNvPr>
-          <p:cNvSpPr>
-            <a:spLocks xmlns:a="http://schemas.openxmlformats.org/drawingml/2006/main" noGrp="1"/>
-          </p:cNvSpPr>
-          <p:nvPr/>
-        </p:nvSpPr>
-        <p:spPr>
-          <a:xfrm xmlns:a="http://schemas.openxmlformats.org/drawingml/2006/main">
-            <a:off x="552450" y="2076450"/>
-            <a:ext cx="914400" cy="323850"/>
-          </a:xfrm>
-          <a:prstGeom xmlns:a="http://schemas.openxmlformats.org/drawingml/2006/main" prst="roundRect">
-            <a:avLst>
-              <a:gd name="adj" fmla="val 50000"/>
-            </a:avLst>
-          </a:prstGeom>
-          <a:solidFill xmlns:a="http://schemas.openxmlformats.org/drawingml/2006/main">
-            <a:srgbClr val="007C77"/>
-          </a:solidFill>
-          <a:ln xmlns:a="http://schemas.openxmlformats.org/drawingml/2006/main" w="9525">
-            <a:solidFill>
-              <a:srgbClr val="007C77"/>
-            </a:solidFill>
-            <a:prstDash val="solid"/>
-          </a:ln>
-        </p:spPr>
-        <p:txBody>
-          <a:bodyPr xmlns:a="http://schemas.openxmlformats.org/drawingml/2006/main" lIns="76200" tIns="0" rIns="76200" bIns="0" anchor="ctr">
-            <a:normAutofit fontScale="100000"/>
-          </a:bodyPr>
-          <a:lstStyle xmlns:a="http://schemas.openxmlformats.org/drawingml/2006/main"/>
-          <a:p xmlns:a="http://schemas.openxmlformats.org/drawingml/2006/main">
-            <a:pPr algn="ctr">
-              <a:buNone/>
-              <a:defRPr sz="1050" b="1">
-                <a:solidFill>
-                  <a:srgbClr val="FFFFFF"/>
-                </a:solidFill>
-                <a:latin typeface="Avenir Next"/>
-                <a:ea typeface="Avenir Next"/>
-                <a:cs typeface="Avenir Next"/>
-              </a:defRPr>
-            </a:pPr>
-            <a:r>
-              <a:rPr sz="1050" b="1">
-                <a:solidFill>
-                  <a:srgbClr val="FFFFFF"/>
-                </a:solidFill>
-                <a:latin typeface="Avenir Next"/>
-                <a:ea typeface="Avenir Next"/>
-                <a:cs typeface="Avenir Next"/>
-              </a:rPr>
-              <a:t>LAB 2</a:t>
-            </a:r>
-          </a:p>
-        </p:txBody>
-      </p:sp>
-      <p:sp>
-        <p:nvSpPr>
-          <p:cNvPr id="6" name="">
-            <a:extLst xmlns:a="http://schemas.openxmlformats.org/drawingml/2006/main">
-              <a:ext uri="{FF2B5EF4-FFF2-40B4-BE49-F238E27FC236}">
-                <a16:creationId xmlns:a16="http://schemas.microsoft.com/office/drawing/2014/main" id="{2645633A-CB17-4789-873C-B16F5F4E2CFD}"/>
-              </a:ext>
-            </a:extLst>
-          </p:cNvPr>
-          <p:cNvSpPr>
-            <a:spLocks xmlns:a="http://schemas.openxmlformats.org/drawingml/2006/main" noGrp="1"/>
-          </p:cNvSpPr>
-          <p:nvPr/>
-        </p:nvSpPr>
-        <p:spPr>
-          <a:xfrm xmlns:a="http://schemas.openxmlformats.org/drawingml/2006/main">
-            <a:off x="552450" y="2647950"/>
-            <a:ext cx="5715000" cy="571500"/>
-          </a:xfrm>
-          <a:prstGeom xmlns:a="http://schemas.openxmlformats.org/drawingml/2006/main" prst="rect">
-            <a:avLst/>
-          </a:prstGeom>
-          <a:noFill xmlns:a="http://schemas.openxmlformats.org/drawingml/2006/main"/>
-          <a:ln xmlns:a="http://schemas.openxmlformats.org/drawingml/2006/main" w="0">
-            <a:noFill/>
-            <a:prstDash val="solid"/>
-          </a:ln>
-        </p:spPr>
-        <p:txBody>
-          <a:bodyPr xmlns:a="http://schemas.openxmlformats.org/drawingml/2006/main" lIns="0" tIns="0" rIns="0" bIns="0" anchor="t">
-            <a:normAutofit fontScale="81260"/>
-          </a:bodyPr>
-          <a:lstStyle xmlns:a="http://schemas.openxmlformats.org/drawingml/2006/main"/>
-          <a:p xmlns:a="http://schemas.openxmlformats.org/drawingml/2006/main">
-            <a:pPr>
-              <a:buNone/>
-              <a:defRPr sz="2325" b="1">
-                <a:solidFill>
-                  <a:srgbClr val="14213D"/>
-                </a:solidFill>
-                <a:latin typeface="Georgia"/>
-                <a:ea typeface="Georgia"/>
-                <a:cs typeface="Georgia"/>
-              </a:defRPr>
-            </a:pPr>
-            <a:r>
-              <a:rPr sz="2325" b="1">
-                <a:solidFill>
-                  <a:srgbClr val="14213D"/>
-                </a:solidFill>
-                <a:latin typeface="Georgia"/>
-                <a:ea typeface="Georgia"/>
-                <a:cs typeface="Georgia"/>
-              </a:rPr>
-              <a:t>Use the users and tickets relations from today.</a:t>
-            </a:r>
-          </a:p>
-        </p:txBody>
-      </p:sp>
-      <p:sp>
-        <p:nvSpPr>
-          <p:cNvPr id="7" name="">
-            <a:extLst xmlns:a="http://schemas.openxmlformats.org/drawingml/2006/main">
-              <a:ext uri="{FF2B5EF4-FFF2-40B4-BE49-F238E27FC236}">
-                <a16:creationId xmlns:a16="http://schemas.microsoft.com/office/drawing/2014/main" id="{CE69F959-B61C-4E32-8263-CD9EFEE77EF6}"/>
-              </a:ext>
-            </a:extLst>
-          </p:cNvPr>
-          <p:cNvSpPr>
-            <a:spLocks xmlns:a="http://schemas.openxmlformats.org/drawingml/2006/main" noGrp="1"/>
-          </p:cNvSpPr>
-          <p:nvPr/>
-        </p:nvSpPr>
-        <p:spPr>
-          <a:xfrm xmlns:a="http://schemas.openxmlformats.org/drawingml/2006/main">
-            <a:off x="552450" y="3524250"/>
-            <a:ext cx="5381625" cy="1952625"/>
-          </a:xfrm>
-          <a:prstGeom xmlns:a="http://schemas.openxmlformats.org/drawingml/2006/main" prst="roundRect">
-            <a:avLst>
-              <a:gd name="adj" fmla="val 8780"/>
-            </a:avLst>
-          </a:prstGeom>
-          <a:solidFill xmlns:a="http://schemas.openxmlformats.org/drawingml/2006/main">
-            <a:srgbClr val="F4F8FF"/>
-          </a:solidFill>
-          <a:ln xmlns:a="http://schemas.openxmlformats.org/drawingml/2006/main" w="9525">
-            <a:solidFill>
-              <a:srgbClr val="E9E4D8"/>
-            </a:solidFill>
-            <a:prstDash val="solid"/>
-          </a:ln>
-        </p:spPr>
-        <p:style>
-          <a:lnRef xmlns:a="http://schemas.openxmlformats.org/drawingml/2006/main" idx="0"/>
-          <a:fillRef xmlns:a="http://schemas.openxmlformats.org/drawingml/2006/main" idx="0"/>
-          <a:effectRef xmlns:a="http://schemas.openxmlformats.org/drawingml/2006/main" idx="4"/>
-          <a:fontRef xmlns:a="http://schemas.openxmlformats.org/drawingml/2006/main" idx="major"/>
-        </p:style>
-      </p:sp>
-      <p:sp>
-        <p:nvSpPr>
-          <p:cNvPr id="8" name="">
-            <a:extLst xmlns:a="http://schemas.openxmlformats.org/drawingml/2006/main">
-              <a:ext uri="{FF2B5EF4-FFF2-40B4-BE49-F238E27FC236}">
-                <a16:creationId xmlns:a16="http://schemas.microsoft.com/office/drawing/2014/main" id="{156973FA-5FE4-4F96-B9F1-0366E268B6B6}"/>
-              </a:ext>
-            </a:extLst>
-          </p:cNvPr>
-          <p:cNvSpPr>
-            <a:spLocks xmlns:a="http://schemas.openxmlformats.org/drawingml/2006/main" noGrp="1"/>
-          </p:cNvSpPr>
-          <p:nvPr/>
-        </p:nvSpPr>
-        <p:spPr>
-          <a:xfrm xmlns:a="http://schemas.openxmlformats.org/drawingml/2006/main">
-            <a:off x="552450" y="3524250"/>
-            <a:ext cx="76200" cy="1952625"/>
-          </a:xfrm>
-          <a:prstGeom xmlns:a="http://schemas.openxmlformats.org/drawingml/2006/main" prst="rect">
-            <a:avLst/>
-          </a:prstGeom>
-          <a:solidFill xmlns:a="http://schemas.openxmlformats.org/drawingml/2006/main">
-            <a:srgbClr val="0B5FFF"/>
-          </a:solidFill>
-          <a:ln xmlns:a="http://schemas.openxmlformats.org/drawingml/2006/main" w="0">
-            <a:solidFill>
-              <a:srgbClr val="0B5FFF"/>
-            </a:solidFill>
-            <a:prstDash val="solid"/>
-          </a:ln>
-        </p:spPr>
-      </p:sp>
-      <p:sp>
-        <p:nvSpPr>
-          <p:cNvPr id="9" name="">
-            <a:extLst xmlns:a="http://schemas.openxmlformats.org/drawingml/2006/main">
-              <a:ext uri="{FF2B5EF4-FFF2-40B4-BE49-F238E27FC236}">
-                <a16:creationId xmlns:a16="http://schemas.microsoft.com/office/drawing/2014/main" id="{17FBB485-4103-4CFA-A935-012D462BF3C3}"/>
-              </a:ext>
-            </a:extLst>
-          </p:cNvPr>
-          <p:cNvSpPr>
-            <a:spLocks xmlns:a="http://schemas.openxmlformats.org/drawingml/2006/main" noGrp="1"/>
-          </p:cNvSpPr>
-          <p:nvPr/>
-        </p:nvSpPr>
-        <p:spPr>
-          <a:xfrm xmlns:a="http://schemas.openxmlformats.org/drawingml/2006/main">
-            <a:off x="800100" y="3714750"/>
-            <a:ext cx="4924425" cy="361950"/>
-          </a:xfrm>
-          <a:prstGeom xmlns:a="http://schemas.openxmlformats.org/drawingml/2006/main" prst="rect">
-            <a:avLst/>
-          </a:prstGeom>
-          <a:noFill xmlns:a="http://schemas.openxmlformats.org/drawingml/2006/main"/>
-          <a:ln xmlns:a="http://schemas.openxmlformats.org/drawingml/2006/main" w="0">
-            <a:noFill/>
-            <a:prstDash val="solid"/>
-          </a:ln>
-        </p:spPr>
-        <p:txBody>
-          <a:bodyPr xmlns:a="http://schemas.openxmlformats.org/drawingml/2006/main" lIns="0" tIns="0" rIns="0" bIns="0" anchor="t">
-            <a:normAutofit fontScale="100000"/>
-          </a:bodyPr>
-          <a:lstStyle xmlns:a="http://schemas.openxmlformats.org/drawingml/2006/main"/>
-          <a:p xmlns:a="http://schemas.openxmlformats.org/drawingml/2006/main">
-            <a:pPr>
-              <a:buNone/>
-              <a:defRPr sz="1725" b="1">
-                <a:solidFill>
-                  <a:srgbClr val="14213D"/>
-                </a:solidFill>
-                <a:latin typeface="Georgia"/>
-                <a:ea typeface="Georgia"/>
-                <a:cs typeface="Georgia"/>
-              </a:defRPr>
-            </a:pPr>
-            <a:r>
-              <a:rPr sz="1725" b="1">
-                <a:solidFill>
-                  <a:srgbClr val="14213D"/>
-                </a:solidFill>
-                <a:latin typeface="Georgia"/>
-                <a:ea typeface="Georgia"/>
-                <a:cs typeface="Georgia"/>
-              </a:rPr>
-              <a:t>Part A · Read</a:t>
-            </a:r>
-          </a:p>
-        </p:txBody>
-      </p:sp>
-      <p:sp>
-        <p:nvSpPr>
-          <p:cNvPr id="10" name="">
-            <a:extLst xmlns:a="http://schemas.openxmlformats.org/drawingml/2006/main">
-              <a:ext uri="{FF2B5EF4-FFF2-40B4-BE49-F238E27FC236}">
-                <a16:creationId xmlns:a16="http://schemas.microsoft.com/office/drawing/2014/main" id="{6235703A-9BD7-4181-BD4A-BF7DB5364A1E}"/>
-              </a:ext>
-            </a:extLst>
-          </p:cNvPr>
-          <p:cNvSpPr>
-            <a:spLocks xmlns:a="http://schemas.openxmlformats.org/drawingml/2006/main" noGrp="1"/>
-          </p:cNvSpPr>
-          <p:nvPr/>
-        </p:nvSpPr>
-        <p:spPr>
-          <a:xfrm xmlns:a="http://schemas.openxmlformats.org/drawingml/2006/main">
-            <a:off x="800100" y="4162425"/>
-            <a:ext cx="4924425" cy="1114425"/>
-          </a:xfrm>
-          <a:prstGeom xmlns:a="http://schemas.openxmlformats.org/drawingml/2006/main" prst="rect">
-            <a:avLst/>
-          </a:prstGeom>
-          <a:noFill xmlns:a="http://schemas.openxmlformats.org/drawingml/2006/main"/>
-          <a:ln xmlns:a="http://schemas.openxmlformats.org/drawingml/2006/main" w="0">
-            <a:noFill/>
-            <a:prstDash val="solid"/>
-          </a:ln>
-        </p:spPr>
-        <p:txBody>
-          <a:bodyPr xmlns:a="http://schemas.openxmlformats.org/drawingml/2006/main" lIns="0" tIns="0" rIns="0" bIns="0" anchor="t">
-            <a:normAutofit fontScale="100000"/>
-          </a:bodyPr>
-          <a:lstStyle xmlns:a="http://schemas.openxmlformats.org/drawingml/2006/main"/>
-          <a:p xmlns:a="http://schemas.openxmlformats.org/drawingml/2006/main">
-            <a:pPr>
-              <a:lnSpc>
-                <a:spcPct val="115000"/>
-              </a:lnSpc>
-              <a:buNone/>
-              <a:defRPr sz="1575">
-                <a:solidFill>
-                  <a:srgbClr val="5C6577"/>
-                </a:solidFill>
-                <a:latin typeface="Avenir Next"/>
-                <a:ea typeface="Avenir Next"/>
-                <a:cs typeface="Avenir Next"/>
-              </a:defRPr>
-            </a:pPr>
-            <a:r>
-              <a:rPr sz="1575">
-                <a:solidFill>
-                  <a:srgbClr val="5C6577"/>
-                </a:solidFill>
-                <a:latin typeface="Avenir Next"/>
-                <a:ea typeface="Avenir Next"/>
-                <a:cs typeface="Avenir Next"/>
-              </a:rPr>
-              <a:t>For three given expressions, state the output attributes and which tuples would appear.</a:t>
-            </a:r>
-          </a:p>
-        </p:txBody>
-      </p:sp>
-      <p:sp>
-        <p:nvSpPr>
-          <p:cNvPr id="11" name="">
-            <a:extLst xmlns:a="http://schemas.openxmlformats.org/drawingml/2006/main">
-              <a:ext uri="{FF2B5EF4-FFF2-40B4-BE49-F238E27FC236}">
-                <a16:creationId xmlns:a16="http://schemas.microsoft.com/office/drawing/2014/main" id="{306318EE-345D-44DB-B67E-15982B4586BA}"/>
-              </a:ext>
-            </a:extLst>
-          </p:cNvPr>
-          <p:cNvSpPr>
-            <a:spLocks xmlns:a="http://schemas.openxmlformats.org/drawingml/2006/main" noGrp="1"/>
-          </p:cNvSpPr>
-          <p:nvPr/>
-        </p:nvSpPr>
-        <p:spPr>
-          <a:xfrm xmlns:a="http://schemas.openxmlformats.org/drawingml/2006/main">
-            <a:off x="6257925" y="3524250"/>
-            <a:ext cx="5381625" cy="1952625"/>
-          </a:xfrm>
-          <a:prstGeom xmlns:a="http://schemas.openxmlformats.org/drawingml/2006/main" prst="roundRect">
-            <a:avLst>
-              <a:gd name="adj" fmla="val 8780"/>
-            </a:avLst>
-          </a:prstGeom>
-          <a:solidFill xmlns:a="http://schemas.openxmlformats.org/drawingml/2006/main">
-            <a:srgbClr val="FFF8EE"/>
-          </a:solidFill>
-          <a:ln xmlns:a="http://schemas.openxmlformats.org/drawingml/2006/main" w="9525">
-            <a:solidFill>
-              <a:srgbClr val="E9E4D8"/>
-            </a:solidFill>
-            <a:prstDash val="solid"/>
-          </a:ln>
-        </p:spPr>
-        <p:style>
-          <a:lnRef xmlns:a="http://schemas.openxmlformats.org/drawingml/2006/main" idx="0"/>
-          <a:fillRef xmlns:a="http://schemas.openxmlformats.org/drawingml/2006/main" idx="0"/>
-          <a:effectRef xmlns:a="http://schemas.openxmlformats.org/drawingml/2006/main" idx="4"/>
-          <a:fontRef xmlns:a="http://schemas.openxmlformats.org/drawingml/2006/main" idx="major"/>
-        </p:style>
-      </p:sp>
-      <p:sp>
-        <p:nvSpPr>
-          <p:cNvPr id="12" name="">
-            <a:extLst xmlns:a="http://schemas.openxmlformats.org/drawingml/2006/main">
-              <a:ext uri="{FF2B5EF4-FFF2-40B4-BE49-F238E27FC236}">
-                <a16:creationId xmlns:a16="http://schemas.microsoft.com/office/drawing/2014/main" id="{99C6E00B-9F52-472D-9059-64096A9F3E70}"/>
-              </a:ext>
-            </a:extLst>
-          </p:cNvPr>
-          <p:cNvSpPr>
-            <a:spLocks xmlns:a="http://schemas.openxmlformats.org/drawingml/2006/main" noGrp="1"/>
-          </p:cNvSpPr>
-          <p:nvPr/>
-        </p:nvSpPr>
-        <p:spPr>
-          <a:xfrm xmlns:a="http://schemas.openxmlformats.org/drawingml/2006/main">
-            <a:off x="6257925" y="3524250"/>
-            <a:ext cx="76200" cy="1952625"/>
-          </a:xfrm>
-          <a:prstGeom xmlns:a="http://schemas.openxmlformats.org/drawingml/2006/main" prst="rect">
-            <a:avLst/>
-          </a:prstGeom>
-          <a:solidFill xmlns:a="http://schemas.openxmlformats.org/drawingml/2006/main">
-            <a:srgbClr val="F4A261"/>
-          </a:solidFill>
-          <a:ln xmlns:a="http://schemas.openxmlformats.org/drawingml/2006/main" w="0">
-            <a:solidFill>
-              <a:srgbClr val="F4A261"/>
-            </a:solidFill>
-            <a:prstDash val="solid"/>
-          </a:ln>
-        </p:spPr>
-      </p:sp>
-      <p:sp>
-        <p:nvSpPr>
-          <p:cNvPr id="13" name="">
-            <a:extLst xmlns:a="http://schemas.openxmlformats.org/drawingml/2006/main">
-              <a:ext uri="{FF2B5EF4-FFF2-40B4-BE49-F238E27FC236}">
-                <a16:creationId xmlns:a16="http://schemas.microsoft.com/office/drawing/2014/main" id="{D5BD0823-17BC-41EC-A0CD-07BB307028DF}"/>
-              </a:ext>
-            </a:extLst>
-          </p:cNvPr>
-          <p:cNvSpPr>
-            <a:spLocks xmlns:a="http://schemas.openxmlformats.org/drawingml/2006/main" noGrp="1"/>
-          </p:cNvSpPr>
-          <p:nvPr/>
-        </p:nvSpPr>
-        <p:spPr>
-          <a:xfrm xmlns:a="http://schemas.openxmlformats.org/drawingml/2006/main">
-            <a:off x="6505575" y="3714750"/>
-            <a:ext cx="4924425" cy="361950"/>
-          </a:xfrm>
-          <a:prstGeom xmlns:a="http://schemas.openxmlformats.org/drawingml/2006/main" prst="rect">
-            <a:avLst/>
-          </a:prstGeom>
-          <a:noFill xmlns:a="http://schemas.openxmlformats.org/drawingml/2006/main"/>
-          <a:ln xmlns:a="http://schemas.openxmlformats.org/drawingml/2006/main" w="0">
-            <a:noFill/>
-            <a:prstDash val="solid"/>
-          </a:ln>
-        </p:spPr>
-        <p:txBody>
-          <a:bodyPr xmlns:a="http://schemas.openxmlformats.org/drawingml/2006/main" lIns="0" tIns="0" rIns="0" bIns="0" anchor="t">
-            <a:normAutofit fontScale="100000"/>
-          </a:bodyPr>
-          <a:lstStyle xmlns:a="http://schemas.openxmlformats.org/drawingml/2006/main"/>
-          <a:p xmlns:a="http://schemas.openxmlformats.org/drawingml/2006/main">
-            <a:pPr>
-              <a:buNone/>
-              <a:defRPr sz="1725" b="1">
-                <a:solidFill>
-                  <a:srgbClr val="14213D"/>
-                </a:solidFill>
-                <a:latin typeface="Georgia"/>
-                <a:ea typeface="Georgia"/>
-                <a:cs typeface="Georgia"/>
-              </a:defRPr>
-            </a:pPr>
-            <a:r>
-              <a:rPr sz="1725" b="1">
-                <a:solidFill>
-                  <a:srgbClr val="14213D"/>
-                </a:solidFill>
-                <a:latin typeface="Georgia"/>
-                <a:ea typeface="Georgia"/>
-                <a:cs typeface="Georgia"/>
-              </a:rPr>
-              <a:t>Part B · Write</a:t>
-            </a:r>
-          </a:p>
-        </p:txBody>
-      </p:sp>
-      <p:sp>
-        <p:nvSpPr>
-          <p:cNvPr id="14" name="">
-            <a:extLst xmlns:a="http://schemas.openxmlformats.org/drawingml/2006/main">
-              <a:ext uri="{FF2B5EF4-FFF2-40B4-BE49-F238E27FC236}">
-                <a16:creationId xmlns:a16="http://schemas.microsoft.com/office/drawing/2014/main" id="{6DB1806F-7171-4AB1-802E-5F59B6342F19}"/>
-              </a:ext>
-            </a:extLst>
-          </p:cNvPr>
-          <p:cNvSpPr>
-            <a:spLocks xmlns:a="http://schemas.openxmlformats.org/drawingml/2006/main" noGrp="1"/>
-          </p:cNvSpPr>
-          <p:nvPr/>
-        </p:nvSpPr>
-        <p:spPr>
-          <a:xfrm xmlns:a="http://schemas.openxmlformats.org/drawingml/2006/main">
-            <a:off x="6505575" y="4162425"/>
-            <a:ext cx="4924425" cy="1114425"/>
-          </a:xfrm>
-          <a:prstGeom xmlns:a="http://schemas.openxmlformats.org/drawingml/2006/main" prst="rect">
-            <a:avLst/>
-          </a:prstGeom>
-          <a:noFill xmlns:a="http://schemas.openxmlformats.org/drawingml/2006/main"/>
-          <a:ln xmlns:a="http://schemas.openxmlformats.org/drawingml/2006/main" w="0">
-            <a:noFill/>
-            <a:prstDash val="solid"/>
-          </a:ln>
-        </p:spPr>
-        <p:txBody>
-          <a:bodyPr xmlns:a="http://schemas.openxmlformats.org/drawingml/2006/main" lIns="0" tIns="0" rIns="0" bIns="0" anchor="t">
-            <a:normAutofit fontScale="100000"/>
-          </a:bodyPr>
-          <a:lstStyle xmlns:a="http://schemas.openxmlformats.org/drawingml/2006/main"/>
-          <a:p xmlns:a="http://schemas.openxmlformats.org/drawingml/2006/main">
-            <a:pPr>
-              <a:lnSpc>
-                <a:spcPct val="115000"/>
-              </a:lnSpc>
-              <a:buNone/>
-              <a:defRPr sz="1575">
-                <a:solidFill>
-                  <a:srgbClr val="5C6577"/>
-                </a:solidFill>
-                <a:latin typeface="Avenir Next"/>
-                <a:ea typeface="Avenir Next"/>
-                <a:cs typeface="Avenir Next"/>
-              </a:defRPr>
-            </a:pPr>
-            <a:r>
-              <a:rPr sz="1575">
-                <a:solidFill>
-                  <a:srgbClr val="5C6577"/>
-                </a:solidFill>
-                <a:latin typeface="Avenir Next"/>
-                <a:ea typeface="Avenir Next"/>
-                <a:cs typeface="Avenir Next"/>
-              </a:rPr>
-              <a:t>For two plain-language questions, write relational algebra and corresponding SQL.</a:t>
-            </a:r>
-          </a:p>
-        </p:txBody>
-      </p:sp>
-      <p:sp>
-        <p:nvSpPr>
-          <p:cNvPr id="15" name="code-block">
-            <a:extLst xmlns:a="http://schemas.openxmlformats.org/drawingml/2006/main">
-              <a:ext uri="{FF2B5EF4-FFF2-40B4-BE49-F238E27FC236}">
-                <a16:creationId xmlns:a16="http://schemas.microsoft.com/office/drawing/2014/main" id="{4F8EA3C9-C97D-4596-8A9E-CCB5D1026C15}"/>
-              </a:ext>
-            </a:extLst>
-          </p:cNvPr>
-          <p:cNvSpPr>
-            <a:spLocks xmlns:a="http://schemas.openxmlformats.org/drawingml/2006/main" noGrp="1"/>
-          </p:cNvSpPr>
-          <p:nvPr/>
-        </p:nvSpPr>
-        <p:spPr>
-          <a:xfrm xmlns:a="http://schemas.openxmlformats.org/drawingml/2006/main">
-            <a:off x="6715125" y="2171700"/>
-            <a:ext cx="4476750" cy="981075"/>
-          </a:xfrm>
-          <a:prstGeom xmlns:a="http://schemas.openxmlformats.org/drawingml/2006/main" prst="roundRect">
-            <a:avLst>
-              <a:gd name="adj" fmla="val 15534"/>
-            </a:avLst>
-          </a:prstGeom>
-          <a:solidFill xmlns:a="http://schemas.openxmlformats.org/drawingml/2006/main">
-            <a:srgbClr val="172033"/>
-          </a:solidFill>
-          <a:ln xmlns:a="http://schemas.openxmlformats.org/drawingml/2006/main" w="9525">
-            <a:solidFill>
-              <a:srgbClr val="2D3953"/>
-            </a:solidFill>
-            <a:prstDash val="solid"/>
-          </a:ln>
-        </p:spPr>
-      </p:sp>
-      <p:sp>
-        <p:nvSpPr>
-          <p:cNvPr id="16" name="">
-            <a:extLst xmlns:a="http://schemas.openxmlformats.org/drawingml/2006/main">
-              <a:ext uri="{FF2B5EF4-FFF2-40B4-BE49-F238E27FC236}">
-                <a16:creationId xmlns:a16="http://schemas.microsoft.com/office/drawing/2014/main" id="{B294913C-5C58-448C-AD5C-B148014E8451}"/>
-              </a:ext>
-            </a:extLst>
-          </p:cNvPr>
-          <p:cNvSpPr>
-            <a:spLocks xmlns:a="http://schemas.openxmlformats.org/drawingml/2006/main" noGrp="1"/>
-          </p:cNvSpPr>
-          <p:nvPr/>
-        </p:nvSpPr>
-        <p:spPr>
-          <a:xfrm xmlns:a="http://schemas.openxmlformats.org/drawingml/2006/main">
-            <a:off x="6924675" y="2305050"/>
-            <a:ext cx="4057650" cy="266700"/>
-          </a:xfrm>
-          <a:prstGeom xmlns:a="http://schemas.openxmlformats.org/drawingml/2006/main" prst="rect">
-            <a:avLst/>
-          </a:prstGeom>
-          <a:noFill xmlns:a="http://schemas.openxmlformats.org/drawingml/2006/main"/>
-          <a:ln xmlns:a="http://schemas.openxmlformats.org/drawingml/2006/main" w="0">
-            <a:noFill/>
-            <a:prstDash val="solid"/>
-          </a:ln>
-        </p:spPr>
-        <p:txBody>
-          <a:bodyPr xmlns:a="http://schemas.openxmlformats.org/drawingml/2006/main" lIns="0" tIns="0" rIns="0" bIns="0" anchor="t">
-            <a:normAutofit fontScale="100000"/>
-          </a:bodyPr>
-          <a:lstStyle xmlns:a="http://schemas.openxmlformats.org/drawingml/2006/main"/>
-          <a:p xmlns:a="http://schemas.openxmlformats.org/drawingml/2006/main">
-            <a:pPr>
-              <a:buNone/>
-              <a:defRPr sz="1050" b="1">
-                <a:solidFill>
-                  <a:srgbClr val="007C77"/>
-                </a:solidFill>
-                <a:latin typeface="Avenir Next"/>
-                <a:ea typeface="Avenir Next"/>
-                <a:cs typeface="Avenir Next"/>
-              </a:defRPr>
-            </a:pPr>
-            <a:r>
-              <a:rPr sz="1050" b="1">
-                <a:solidFill>
-                  <a:srgbClr val="007C77"/>
-                </a:solidFill>
-                <a:latin typeface="Avenir Next"/>
-                <a:ea typeface="Avenir Next"/>
-                <a:cs typeface="Avenir Next"/>
-              </a:rPr>
-              <a:t>CREATE THIS FILE</a:t>
-            </a:r>
-          </a:p>
-        </p:txBody>
-      </p:sp>
-      <p:sp>
-        <p:nvSpPr>
-          <p:cNvPr id="17" name="">
-            <a:extLst xmlns:a="http://schemas.openxmlformats.org/drawingml/2006/main">
-              <a:ext uri="{FF2B5EF4-FFF2-40B4-BE49-F238E27FC236}">
-                <a16:creationId xmlns:a16="http://schemas.microsoft.com/office/drawing/2014/main" id="{FFEFE903-BA82-4D0C-9E69-1A35218EC75D}"/>
-              </a:ext>
-            </a:extLst>
-          </p:cNvPr>
-          <p:cNvSpPr>
-            <a:spLocks xmlns:a="http://schemas.openxmlformats.org/drawingml/2006/main" noGrp="1"/>
-          </p:cNvSpPr>
-          <p:nvPr/>
-        </p:nvSpPr>
-        <p:spPr>
-          <a:xfrm xmlns:a="http://schemas.openxmlformats.org/drawingml/2006/main">
-            <a:off x="6924675" y="2647950"/>
-            <a:ext cx="4057650" cy="352425"/>
-          </a:xfrm>
-          <a:prstGeom xmlns:a="http://schemas.openxmlformats.org/drawingml/2006/main" prst="rect">
-            <a:avLst/>
-          </a:prstGeom>
-          <a:noFill xmlns:a="http://schemas.openxmlformats.org/drawingml/2006/main"/>
-          <a:ln xmlns:a="http://schemas.openxmlformats.org/drawingml/2006/main" w="0">
-            <a:noFill/>
-            <a:prstDash val="solid"/>
-          </a:ln>
-        </p:spPr>
-        <p:txBody>
-          <a:bodyPr xmlns:a="http://schemas.openxmlformats.org/drawingml/2006/main" lIns="0" tIns="0" rIns="0" bIns="0" anchor="t">
-            <a:normAutofit fontScale="100000"/>
-          </a:bodyPr>
-          <a:lstStyle xmlns:a="http://schemas.openxmlformats.org/drawingml/2006/main"/>
-          <a:p xmlns:a="http://schemas.openxmlformats.org/drawingml/2006/main">
-            <a:pPr>
-              <a:lnSpc>
-                <a:spcPct val="115000"/>
-              </a:lnSpc>
-              <a:buNone/>
-              <a:defRPr sz="1500">
-                <a:solidFill>
-                  <a:srgbClr val="F8FAFC"/>
-                </a:solidFill>
-                <a:latin typeface="Menlo"/>
-                <a:ea typeface="Menlo"/>
-                <a:cs typeface="Menlo"/>
-              </a:defRPr>
-            </a:pPr>
-            <a:r>
-              <a:rPr sz="1500">
-                <a:solidFill>
-                  <a:srgbClr val="F8FAFC"/>
-                </a:solidFill>
-                <a:latin typeface="Menlo"/>
-                <a:ea typeface="Menlo"/>
-                <a:cs typeface="Menlo"/>
-              </a:rPr>
-              <a:t>week_01/relational_reasoning.md</a:t>
-            </a:r>
-          </a:p>
-        </p:txBody>
-      </p:sp>
-      <p:sp>
-        <p:nvSpPr>
-          <p:cNvPr id="18" name="">
-            <a:extLst xmlns:a="http://schemas.openxmlformats.org/drawingml/2006/main">
-              <a:ext uri="{FF2B5EF4-FFF2-40B4-BE49-F238E27FC236}">
-                <a16:creationId xmlns:a16="http://schemas.microsoft.com/office/drawing/2014/main" id="{F6E0C3D9-3B61-4A58-816A-43CBB43AC91F}"/>
-              </a:ext>
-            </a:extLst>
-          </p:cNvPr>
-          <p:cNvSpPr>
-            <a:spLocks xmlns:a="http://schemas.openxmlformats.org/drawingml/2006/main" noGrp="1"/>
-          </p:cNvSpPr>
-          <p:nvPr/>
-        </p:nvSpPr>
-        <p:spPr>
-          <a:xfrm xmlns:a="http://schemas.openxmlformats.org/drawingml/2006/main">
-            <a:off x="3000375" y="5819775"/>
-            <a:ext cx="6191250" cy="323850"/>
-          </a:xfrm>
-          <a:prstGeom xmlns:a="http://schemas.openxmlformats.org/drawingml/2006/main" prst="rect">
-            <a:avLst/>
-          </a:prstGeom>
-          <a:noFill xmlns:a="http://schemas.openxmlformats.org/drawingml/2006/main"/>
-          <a:ln xmlns:a="http://schemas.openxmlformats.org/drawingml/2006/main" w="0">
-            <a:noFill/>
-            <a:prstDash val="solid"/>
-          </a:ln>
-        </p:spPr>
-        <p:txBody>
-          <a:bodyPr xmlns:a="http://schemas.openxmlformats.org/drawingml/2006/main" lIns="0" tIns="0" rIns="0" bIns="0" anchor="t">
-            <a:normAutofit fontScale="100000"/>
-          </a:bodyPr>
-          <a:lstStyle xmlns:a="http://schemas.openxmlformats.org/drawingml/2006/main"/>
-          <a:p xmlns:a="http://schemas.openxmlformats.org/drawingml/2006/main">
-            <a:pPr algn="ctr">
-              <a:buNone/>
-              <a:defRPr sz="1575" b="1">
-                <a:solidFill>
-                  <a:srgbClr val="007C77"/>
-                </a:solidFill>
-                <a:latin typeface="Avenir Next"/>
-                <a:ea typeface="Avenir Next"/>
-                <a:cs typeface="Avenir Next"/>
-              </a:defRPr>
-            </a:pPr>
-            <a:r>
-              <a:rPr sz="1575" b="1">
-                <a:solidFill>
-                  <a:srgbClr val="007C77"/>
-                </a:solidFill>
-                <a:latin typeface="Avenir Next"/>
-                <a:ea typeface="Avenir Next"/>
-                <a:cs typeface="Avenir Next"/>
-              </a:rPr>
-              <a:t>Submit the file URL before leaving class.</a:t>
-            </a:r>
-          </a:p>
-        </p:txBody>
-      </p:sp>
-    </p:spTree>
-    <p:extLst>
-      <p:ext uri="{BB962C8B-B14F-4D97-AF65-F5344CB8AC3E}">
-        <p14:creationId xmlns:p14="http://schemas.microsoft.com/office/powerpoint/2010/main" val="609366367"/>
-      </p:ext>
-    </p:extLst>
-  </p:cSld>
-</p:sld>
-</file>
-
 <file path=ppt/slides/slide2.xml><?xml version="1.0" encoding="utf-8"?>
 <p:sld xmlns:p="http://schemas.openxmlformats.org/presentationml/2006/main">
   <p:cSld>
@@ -23190,1296 +20574,6 @@
     <p:extLst>
       <p:ext uri="{BB962C8B-B14F-4D97-AF65-F5344CB8AC3E}">
         <p14:creationId xmlns:p14="http://schemas.microsoft.com/office/powerpoint/2010/main" val="1272352895"/>
-      </p:ext>
-    </p:extLst>
-  </p:cSld>
-</p:sld>
-</file>
-
-<file path=ppt/slides/slide9.xml><?xml version="1.0" encoding="utf-8"?>
-<p:sld xmlns:p="http://schemas.openxmlformats.org/presentationml/2006/main">
-  <p:cSld>
-    <p:bg>
-      <p:bgPr>
-        <a:solidFill xmlns:a="http://schemas.openxmlformats.org/drawingml/2006/main">
-          <a:srgbClr val="F7F3EA"/>
-        </a:solidFill>
-      </p:bgPr>
-    </p:bg>
-    <p:spTree>
-      <p:nvGrpSpPr>
-        <p:cNvPr id="1" name=""/>
-        <p:cNvGrpSpPr/>
-        <p:nvPr/>
-      </p:nvGrpSpPr>
-      <p:grpSpPr>
-        <a:xfrm xmlns:a="http://schemas.openxmlformats.org/drawingml/2006/main"/>
-      </p:grpSpPr>
-      <p:sp>
-        <p:nvSpPr>
-          <p:cNvPr id="20" name="">
-            <a:extLst xmlns:a="http://schemas.openxmlformats.org/drawingml/2006/main">
-              <a:ext uri="{FF2B5EF4-FFF2-40B4-BE49-F238E27FC236}">
-                <a16:creationId xmlns:a16="http://schemas.microsoft.com/office/drawing/2014/main" id="{5F901482-ACEE-4500-BDA4-BF1706155893}"/>
-              </a:ext>
-            </a:extLst>
-          </p:cNvPr>
-          <p:cNvSpPr>
-            <a:spLocks xmlns:a="http://schemas.openxmlformats.org/drawingml/2006/main" noGrp="1"/>
-          </p:cNvSpPr>
-          <p:nvPr/>
-        </p:nvSpPr>
-        <p:spPr>
-          <a:xfrm xmlns:a="http://schemas.openxmlformats.org/drawingml/2006/main">
-            <a:off x="552450" y="400050"/>
-            <a:ext cx="1447800" cy="323850"/>
-          </a:xfrm>
-          <a:prstGeom xmlns:a="http://schemas.openxmlformats.org/drawingml/2006/main" prst="roundRect">
-            <a:avLst>
-              <a:gd name="adj" fmla="val 50000"/>
-            </a:avLst>
-          </a:prstGeom>
-          <a:solidFill xmlns:a="http://schemas.openxmlformats.org/drawingml/2006/main">
-            <a:srgbClr val="14213D"/>
-          </a:solidFill>
-          <a:ln xmlns:a="http://schemas.openxmlformats.org/drawingml/2006/main" w="9525">
-            <a:solidFill>
-              <a:srgbClr val="14213D"/>
-            </a:solidFill>
-            <a:prstDash val="solid"/>
-          </a:ln>
-        </p:spPr>
-        <p:txBody>
-          <a:bodyPr xmlns:a="http://schemas.openxmlformats.org/drawingml/2006/main" lIns="76200" tIns="0" rIns="76200" bIns="0" anchor="ctr">
-            <a:normAutofit fontScale="85232"/>
-          </a:bodyPr>
-          <a:lstStyle xmlns:a="http://schemas.openxmlformats.org/drawingml/2006/main"/>
-          <a:p xmlns:a="http://schemas.openxmlformats.org/drawingml/2006/main">
-            <a:pPr algn="ctr">
-              <a:buNone/>
-              <a:defRPr sz="1050" b="1">
-                <a:solidFill>
-                  <a:srgbClr val="FFFFFF"/>
-                </a:solidFill>
-                <a:latin typeface="Avenir Next"/>
-                <a:ea typeface="Avenir Next"/>
-                <a:cs typeface="Avenir Next"/>
-              </a:defRPr>
-            </a:pPr>
-            <a:r>
-              <a:rPr sz="1050" b="1">
-                <a:solidFill>
-                  <a:srgbClr val="FFFFFF"/>
-                </a:solidFill>
-                <a:latin typeface="Avenir Next"/>
-                <a:ea typeface="Avenir Next"/>
-                <a:cs typeface="Avenir Next"/>
-              </a:rPr>
-              <a:t>COURSE WORKFLOW</a:t>
-            </a:r>
-          </a:p>
-        </p:txBody>
-      </p:sp>
-      <p:sp>
-        <p:nvSpPr>
-          <p:cNvPr id="2" name="slide-title">
-            <a:extLst xmlns:a="http://schemas.openxmlformats.org/drawingml/2006/main">
-              <a:ext uri="{FF2B5EF4-FFF2-40B4-BE49-F238E27FC236}">
-                <a16:creationId xmlns:a16="http://schemas.microsoft.com/office/drawing/2014/main" id="{731D4682-C229-44A9-9356-9360E103067F}"/>
-              </a:ext>
-            </a:extLst>
-          </p:cNvPr>
-          <p:cNvSpPr>
-            <a:spLocks xmlns:a="http://schemas.openxmlformats.org/drawingml/2006/main" noGrp="1"/>
-          </p:cNvSpPr>
-          <p:nvPr/>
-        </p:nvSpPr>
-        <p:spPr>
-          <a:xfrm xmlns:a="http://schemas.openxmlformats.org/drawingml/2006/main">
-            <a:off x="552450" y="876300"/>
-            <a:ext cx="11087100" cy="704850"/>
-          </a:xfrm>
-          <a:prstGeom xmlns:a="http://schemas.openxmlformats.org/drawingml/2006/main" prst="rect">
-            <a:avLst/>
-          </a:prstGeom>
-          <a:noFill xmlns:a="http://schemas.openxmlformats.org/drawingml/2006/main"/>
-          <a:ln xmlns:a="http://schemas.openxmlformats.org/drawingml/2006/main" w="0">
-            <a:noFill/>
-            <a:prstDash val="solid"/>
-          </a:ln>
-        </p:spPr>
-        <p:txBody>
-          <a:bodyPr xmlns:a="http://schemas.openxmlformats.org/drawingml/2006/main" lIns="0" tIns="0" rIns="0" bIns="0" anchor="t">
-            <a:normAutofit fontScale="100000"/>
-          </a:bodyPr>
-          <a:lstStyle xmlns:a="http://schemas.openxmlformats.org/drawingml/2006/main"/>
-          <a:p xmlns:a="http://schemas.openxmlformats.org/drawingml/2006/main">
-            <a:pPr>
-              <a:lnSpc>
-                <a:spcPct val="95000"/>
-              </a:lnSpc>
-              <a:buNone/>
-              <a:defRPr sz="3000" b="1">
-                <a:solidFill>
-                  <a:srgbClr val="14213D"/>
-                </a:solidFill>
-                <a:latin typeface="Georgia"/>
-                <a:ea typeface="Georgia"/>
-                <a:cs typeface="Georgia"/>
-              </a:defRPr>
-            </a:pPr>
-            <a:r>
-              <a:rPr sz="3000" b="1">
-                <a:solidFill>
-                  <a:srgbClr val="14213D"/>
-                </a:solidFill>
-                <a:latin typeface="Georgia"/>
-                <a:ea typeface="Georgia"/>
-                <a:cs typeface="Georgia"/>
-              </a:rPr>
-              <a:t>GitHub’s browser editor is enough for today</a:t>
-            </a:r>
-          </a:p>
-        </p:txBody>
-      </p:sp>
-      <p:sp>
-        <p:nvSpPr>
-          <p:cNvPr id="3" name="">
-            <a:extLst xmlns:a="http://schemas.openxmlformats.org/drawingml/2006/main">
-              <a:ext uri="{FF2B5EF4-FFF2-40B4-BE49-F238E27FC236}">
-                <a16:creationId xmlns:a16="http://schemas.microsoft.com/office/drawing/2014/main" id="{8F287271-6756-488B-948F-3954C6686772}"/>
-              </a:ext>
-            </a:extLst>
-          </p:cNvPr>
-          <p:cNvSpPr>
-            <a:spLocks xmlns:a="http://schemas.openxmlformats.org/drawingml/2006/main" noGrp="1"/>
-          </p:cNvSpPr>
-          <p:nvPr/>
-        </p:nvSpPr>
-        <p:spPr>
-          <a:xfrm xmlns:a="http://schemas.openxmlformats.org/drawingml/2006/main">
-            <a:off x="571500" y="1562100"/>
-            <a:ext cx="10477500" cy="381000"/>
-          </a:xfrm>
-          <a:prstGeom xmlns:a="http://schemas.openxmlformats.org/drawingml/2006/main" prst="rect">
-            <a:avLst/>
-          </a:prstGeom>
-          <a:noFill xmlns:a="http://schemas.openxmlformats.org/drawingml/2006/main"/>
-          <a:ln xmlns:a="http://schemas.openxmlformats.org/drawingml/2006/main" w="0">
-            <a:noFill/>
-            <a:prstDash val="solid"/>
-          </a:ln>
-        </p:spPr>
-        <p:txBody>
-          <a:bodyPr xmlns:a="http://schemas.openxmlformats.org/drawingml/2006/main" lIns="0" tIns="0" rIns="0" bIns="0" anchor="t">
-            <a:normAutofit fontScale="100000"/>
-          </a:bodyPr>
-          <a:lstStyle xmlns:a="http://schemas.openxmlformats.org/drawingml/2006/main"/>
-          <a:p xmlns:a="http://schemas.openxmlformats.org/drawingml/2006/main">
-            <a:pPr>
-              <a:buNone/>
-              <a:defRPr sz="1425">
-                <a:solidFill>
-                  <a:srgbClr val="5C6577"/>
-                </a:solidFill>
-                <a:latin typeface="Avenir Next"/>
-                <a:ea typeface="Avenir Next"/>
-                <a:cs typeface="Avenir Next"/>
-              </a:defRPr>
-            </a:pPr>
-            <a:r>
-              <a:rPr sz="1425">
-                <a:solidFill>
-                  <a:srgbClr val="5C6577"/>
-                </a:solidFill>
-                <a:latin typeface="Avenir Next"/>
-                <a:ea typeface="Avenir Next"/>
-                <a:cs typeface="Avenir Next"/>
-              </a:rPr>
-              <a:t>Write Markdown in the repository, preview it, and submit the file URL.</a:t>
-            </a:r>
-          </a:p>
-        </p:txBody>
-      </p:sp>
-      <p:sp>
-        <p:nvSpPr>
-          <p:cNvPr id="4" name="">
-            <a:extLst xmlns:a="http://schemas.openxmlformats.org/drawingml/2006/main">
-              <a:ext uri="{FF2B5EF4-FFF2-40B4-BE49-F238E27FC236}">
-                <a16:creationId xmlns:a16="http://schemas.microsoft.com/office/drawing/2014/main" id="{46CBC9AE-6E42-4F2E-8D5F-96F3DED2C39F}"/>
-              </a:ext>
-            </a:extLst>
-          </p:cNvPr>
-          <p:cNvSpPr>
-            <a:spLocks xmlns:a="http://schemas.openxmlformats.org/drawingml/2006/main" noGrp="1"/>
-          </p:cNvSpPr>
-          <p:nvPr/>
-        </p:nvSpPr>
-        <p:spPr>
-          <a:xfrm xmlns:a="http://schemas.openxmlformats.org/drawingml/2006/main">
-            <a:off x="11144250" y="6334125"/>
-            <a:ext cx="495300" cy="228600"/>
-          </a:xfrm>
-          <a:prstGeom xmlns:a="http://schemas.openxmlformats.org/drawingml/2006/main" prst="rect">
-            <a:avLst/>
-          </a:prstGeom>
-          <a:noFill xmlns:a="http://schemas.openxmlformats.org/drawingml/2006/main"/>
-          <a:ln xmlns:a="http://schemas.openxmlformats.org/drawingml/2006/main" w="0">
-            <a:noFill/>
-            <a:prstDash val="solid"/>
-          </a:ln>
-        </p:spPr>
-        <p:txBody>
-          <a:bodyPr xmlns:a="http://schemas.openxmlformats.org/drawingml/2006/main" lIns="0" tIns="0" rIns="0" bIns="0" anchor="t">
-            <a:normAutofit fontScale="100000"/>
-          </a:bodyPr>
-          <a:lstStyle xmlns:a="http://schemas.openxmlformats.org/drawingml/2006/main"/>
-          <a:p xmlns:a="http://schemas.openxmlformats.org/drawingml/2006/main">
-            <a:pPr algn="r">
-              <a:buNone/>
-              <a:defRPr sz="1050" b="1">
-                <a:solidFill>
-                  <a:srgbClr val="5C6577"/>
-                </a:solidFill>
-                <a:latin typeface="Menlo"/>
-                <a:ea typeface="Menlo"/>
-                <a:cs typeface="Menlo"/>
-              </a:defRPr>
-            </a:pPr>
-            <a:r>
-              <a:rPr sz="1050" b="1">
-                <a:solidFill>
-                  <a:srgbClr val="5C6577"/>
-                </a:solidFill>
-                <a:latin typeface="Menlo"/>
-                <a:ea typeface="Menlo"/>
-                <a:cs typeface="Menlo"/>
-              </a:rPr>
-              <a:t>09</a:t>
-            </a:r>
-          </a:p>
-        </p:txBody>
-      </p:sp>
-      <p:sp>
-        <p:nvSpPr>
-          <p:cNvPr id="5" name="">
-            <a:extLst xmlns:a="http://schemas.openxmlformats.org/drawingml/2006/main">
-              <a:ext uri="{FF2B5EF4-FFF2-40B4-BE49-F238E27FC236}">
-                <a16:creationId xmlns:a16="http://schemas.microsoft.com/office/drawing/2014/main" id="{370F3191-C6F5-4D5E-B8DA-AE34CECACD77}"/>
-              </a:ext>
-            </a:extLst>
-          </p:cNvPr>
-          <p:cNvSpPr>
-            <a:spLocks xmlns:a="http://schemas.openxmlformats.org/drawingml/2006/main" noGrp="1"/>
-          </p:cNvSpPr>
-          <p:nvPr/>
-        </p:nvSpPr>
-        <p:spPr>
-          <a:xfrm xmlns:a="http://schemas.openxmlformats.org/drawingml/2006/main">
-            <a:off x="552450" y="2095500"/>
-            <a:ext cx="7000875" cy="3857625"/>
-          </a:xfrm>
-          <a:prstGeom xmlns:a="http://schemas.openxmlformats.org/drawingml/2006/main" prst="roundRect">
-            <a:avLst>
-              <a:gd name="adj" fmla="val 3951"/>
-            </a:avLst>
-          </a:prstGeom>
-          <a:solidFill xmlns:a="http://schemas.openxmlformats.org/drawingml/2006/main">
-            <a:srgbClr val="FFFFFF"/>
-          </a:solidFill>
-          <a:ln xmlns:a="http://schemas.openxmlformats.org/drawingml/2006/main" w="19050">
-            <a:solidFill>
-              <a:srgbClr val="B7BFCC"/>
-            </a:solidFill>
-            <a:prstDash val="solid"/>
-          </a:ln>
-        </p:spPr>
-      </p:sp>
-      <p:sp>
-        <p:nvSpPr>
-          <p:cNvPr id="6" name="">
-            <a:extLst xmlns:a="http://schemas.openxmlformats.org/drawingml/2006/main">
-              <a:ext uri="{FF2B5EF4-FFF2-40B4-BE49-F238E27FC236}">
-                <a16:creationId xmlns:a16="http://schemas.microsoft.com/office/drawing/2014/main" id="{A6BBA22B-04BE-44E7-8947-9C8DE07F87CA}"/>
-              </a:ext>
-            </a:extLst>
-          </p:cNvPr>
-          <p:cNvSpPr>
-            <a:spLocks xmlns:a="http://schemas.openxmlformats.org/drawingml/2006/main" noGrp="1"/>
-          </p:cNvSpPr>
-          <p:nvPr/>
-        </p:nvSpPr>
-        <p:spPr>
-          <a:xfrm xmlns:a="http://schemas.openxmlformats.org/drawingml/2006/main">
-            <a:off x="571500" y="2114550"/>
-            <a:ext cx="6962775" cy="514350"/>
-          </a:xfrm>
-          <a:prstGeom xmlns:a="http://schemas.openxmlformats.org/drawingml/2006/main" prst="rect">
-            <a:avLst/>
-          </a:prstGeom>
-          <a:solidFill xmlns:a="http://schemas.openxmlformats.org/drawingml/2006/main">
-            <a:srgbClr val="E7EAF0"/>
-          </a:solidFill>
-          <a:ln xmlns:a="http://schemas.openxmlformats.org/drawingml/2006/main" w="9525">
-            <a:solidFill>
-              <a:srgbClr val="B7BFCC"/>
-            </a:solidFill>
-            <a:prstDash val="solid"/>
-          </a:ln>
-        </p:spPr>
-      </p:sp>
-      <p:sp>
-        <p:nvSpPr>
-          <p:cNvPr id="7" name="">
-            <a:extLst xmlns:a="http://schemas.openxmlformats.org/drawingml/2006/main">
-              <a:ext uri="{FF2B5EF4-FFF2-40B4-BE49-F238E27FC236}">
-                <a16:creationId xmlns:a16="http://schemas.microsoft.com/office/drawing/2014/main" id="{29CD2D57-3165-405F-B7B3-0A2964FBDA9B}"/>
-              </a:ext>
-            </a:extLst>
-          </p:cNvPr>
-          <p:cNvSpPr>
-            <a:spLocks xmlns:a="http://schemas.openxmlformats.org/drawingml/2006/main" noGrp="1"/>
-          </p:cNvSpPr>
-          <p:nvPr/>
-        </p:nvSpPr>
-        <p:spPr>
-          <a:xfrm xmlns:a="http://schemas.openxmlformats.org/drawingml/2006/main">
-            <a:off x="838200" y="2209800"/>
-            <a:ext cx="3429000" cy="323850"/>
-          </a:xfrm>
-          <a:prstGeom xmlns:a="http://schemas.openxmlformats.org/drawingml/2006/main" prst="roundRect">
-            <a:avLst>
-              <a:gd name="adj" fmla="val 50000"/>
-            </a:avLst>
-          </a:prstGeom>
-          <a:solidFill xmlns:a="http://schemas.openxmlformats.org/drawingml/2006/main">
-            <a:srgbClr val="FFFFFF"/>
-          </a:solidFill>
-          <a:ln xmlns:a="http://schemas.openxmlformats.org/drawingml/2006/main" w="9525">
-            <a:solidFill>
-              <a:srgbClr val="FFFFFF"/>
-            </a:solidFill>
-            <a:prstDash val="solid"/>
-          </a:ln>
-        </p:spPr>
-        <p:txBody>
-          <a:bodyPr xmlns:a="http://schemas.openxmlformats.org/drawingml/2006/main" lIns="76200" tIns="0" rIns="76200" bIns="0" anchor="ctr">
-            <a:normAutofit fontScale="100000"/>
-          </a:bodyPr>
-          <a:lstStyle xmlns:a="http://schemas.openxmlformats.org/drawingml/2006/main"/>
-          <a:p xmlns:a="http://schemas.openxmlformats.org/drawingml/2006/main">
-            <a:pPr algn="ctr">
-              <a:buNone/>
-              <a:defRPr sz="1050" b="1">
-                <a:solidFill>
-                  <a:srgbClr val="5C6577"/>
-                </a:solidFill>
-                <a:latin typeface="Avenir Next"/>
-                <a:ea typeface="Avenir Next"/>
-                <a:cs typeface="Avenir Next"/>
-              </a:defRPr>
-            </a:pPr>
-            <a:r>
-              <a:rPr sz="1050" b="1">
-                <a:solidFill>
-                  <a:srgbClr val="5C6577"/>
-                </a:solidFill>
-                <a:latin typeface="Avenir Next"/>
-                <a:ea typeface="Avenir Next"/>
-                <a:cs typeface="Avenir Next"/>
-              </a:rPr>
-              <a:t>github.com / your-repository</a:t>
-            </a:r>
-          </a:p>
-        </p:txBody>
-      </p:sp>
-      <p:sp>
-        <p:nvSpPr>
-          <p:cNvPr id="8" name="">
-            <a:extLst xmlns:a="http://schemas.openxmlformats.org/drawingml/2006/main">
-              <a:ext uri="{FF2B5EF4-FFF2-40B4-BE49-F238E27FC236}">
-                <a16:creationId xmlns:a16="http://schemas.microsoft.com/office/drawing/2014/main" id="{527A1D47-7539-4787-B54F-8ACF0502601C}"/>
-              </a:ext>
-            </a:extLst>
-          </p:cNvPr>
-          <p:cNvSpPr>
-            <a:spLocks xmlns:a="http://schemas.openxmlformats.org/drawingml/2006/main" noGrp="1"/>
-          </p:cNvSpPr>
-          <p:nvPr/>
-        </p:nvSpPr>
-        <p:spPr>
-          <a:xfrm xmlns:a="http://schemas.openxmlformats.org/drawingml/2006/main">
-            <a:off x="838200" y="2819400"/>
-            <a:ext cx="4000500" cy="285750"/>
-          </a:xfrm>
-          <a:prstGeom xmlns:a="http://schemas.openxmlformats.org/drawingml/2006/main" prst="rect">
-            <a:avLst/>
-          </a:prstGeom>
-          <a:noFill xmlns:a="http://schemas.openxmlformats.org/drawingml/2006/main"/>
-          <a:ln xmlns:a="http://schemas.openxmlformats.org/drawingml/2006/main" w="0">
-            <a:noFill/>
-            <a:prstDash val="solid"/>
-          </a:ln>
-        </p:spPr>
-        <p:txBody>
-          <a:bodyPr xmlns:a="http://schemas.openxmlformats.org/drawingml/2006/main" lIns="0" tIns="0" rIns="0" bIns="0" anchor="t">
-            <a:normAutofit fontScale="100000"/>
-          </a:bodyPr>
-          <a:lstStyle xmlns:a="http://schemas.openxmlformats.org/drawingml/2006/main"/>
-          <a:p xmlns:a="http://schemas.openxmlformats.org/drawingml/2006/main">
-            <a:pPr>
-              <a:buNone/>
-              <a:defRPr sz="1350" b="1">
-                <a:solidFill>
-                  <a:srgbClr val="14213D"/>
-                </a:solidFill>
-                <a:latin typeface="Menlo"/>
-                <a:ea typeface="Menlo"/>
-                <a:cs typeface="Menlo"/>
-              </a:defRPr>
-            </a:pPr>
-            <a:r>
-              <a:rPr sz="1350" b="1">
-                <a:solidFill>
-                  <a:srgbClr val="14213D"/>
-                </a:solidFill>
-                <a:latin typeface="Menlo"/>
-                <a:ea typeface="Menlo"/>
-                <a:cs typeface="Menlo"/>
-              </a:rPr>
-              <a:t>app_database_map.md</a:t>
-            </a:r>
-          </a:p>
-        </p:txBody>
-      </p:sp>
-      <p:sp>
-        <p:nvSpPr>
-          <p:cNvPr id="9" name="code-block">
-            <a:extLst xmlns:a="http://schemas.openxmlformats.org/drawingml/2006/main">
-              <a:ext uri="{FF2B5EF4-FFF2-40B4-BE49-F238E27FC236}">
-                <a16:creationId xmlns:a16="http://schemas.microsoft.com/office/drawing/2014/main" id="{E44B4206-8D78-4325-933B-57C66AA73ABA}"/>
-              </a:ext>
-            </a:extLst>
-          </p:cNvPr>
-          <p:cNvSpPr>
-            <a:spLocks xmlns:a="http://schemas.openxmlformats.org/drawingml/2006/main" noGrp="1"/>
-          </p:cNvSpPr>
-          <p:nvPr/>
-        </p:nvSpPr>
-        <p:spPr>
-          <a:xfrm xmlns:a="http://schemas.openxmlformats.org/drawingml/2006/main">
-            <a:off x="838200" y="3257550"/>
-            <a:ext cx="6429375" cy="2381250"/>
-          </a:xfrm>
-          <a:prstGeom xmlns:a="http://schemas.openxmlformats.org/drawingml/2006/main" prst="roundRect">
-            <a:avLst>
-              <a:gd name="adj" fmla="val 6400"/>
-            </a:avLst>
-          </a:prstGeom>
-          <a:solidFill xmlns:a="http://schemas.openxmlformats.org/drawingml/2006/main">
-            <a:srgbClr val="172033"/>
-          </a:solidFill>
-          <a:ln xmlns:a="http://schemas.openxmlformats.org/drawingml/2006/main" w="9525">
-            <a:solidFill>
-              <a:srgbClr val="2D3953"/>
-            </a:solidFill>
-            <a:prstDash val="solid"/>
-          </a:ln>
-        </p:spPr>
-      </p:sp>
-      <p:sp>
-        <p:nvSpPr>
-          <p:cNvPr id="10" name="">
-            <a:extLst xmlns:a="http://schemas.openxmlformats.org/drawingml/2006/main">
-              <a:ext uri="{FF2B5EF4-FFF2-40B4-BE49-F238E27FC236}">
-                <a16:creationId xmlns:a16="http://schemas.microsoft.com/office/drawing/2014/main" id="{37B70E6E-304D-44EA-8951-9D172889F1E6}"/>
-              </a:ext>
-            </a:extLst>
-          </p:cNvPr>
-          <p:cNvSpPr>
-            <a:spLocks xmlns:a="http://schemas.openxmlformats.org/drawingml/2006/main" noGrp="1"/>
-          </p:cNvSpPr>
-          <p:nvPr/>
-        </p:nvSpPr>
-        <p:spPr>
-          <a:xfrm xmlns:a="http://schemas.openxmlformats.org/drawingml/2006/main">
-            <a:off x="1047750" y="3390900"/>
-            <a:ext cx="6010275" cy="266700"/>
-          </a:xfrm>
-          <a:prstGeom xmlns:a="http://schemas.openxmlformats.org/drawingml/2006/main" prst="rect">
-            <a:avLst/>
-          </a:prstGeom>
-          <a:noFill xmlns:a="http://schemas.openxmlformats.org/drawingml/2006/main"/>
-          <a:ln xmlns:a="http://schemas.openxmlformats.org/drawingml/2006/main" w="0">
-            <a:noFill/>
-            <a:prstDash val="solid"/>
-          </a:ln>
-        </p:spPr>
-        <p:txBody>
-          <a:bodyPr xmlns:a="http://schemas.openxmlformats.org/drawingml/2006/main" lIns="0" tIns="0" rIns="0" bIns="0" anchor="t">
-            <a:normAutofit fontScale="100000"/>
-          </a:bodyPr>
-          <a:lstStyle xmlns:a="http://schemas.openxmlformats.org/drawingml/2006/main"/>
-          <a:p xmlns:a="http://schemas.openxmlformats.org/drawingml/2006/main">
-            <a:pPr>
-              <a:buNone/>
-              <a:defRPr sz="1050" b="1">
-                <a:solidFill>
-                  <a:srgbClr val="0B5FFF"/>
-                </a:solidFill>
-                <a:latin typeface="Avenir Next"/>
-                <a:ea typeface="Avenir Next"/>
-                <a:cs typeface="Avenir Next"/>
-              </a:defRPr>
-            </a:pPr>
-            <a:r>
-              <a:rPr sz="1050" b="1">
-                <a:solidFill>
-                  <a:srgbClr val="0B5FFF"/>
-                </a:solidFill>
-                <a:latin typeface="Avenir Next"/>
-                <a:ea typeface="Avenir Next"/>
-                <a:cs typeface="Avenir Next"/>
-              </a:rPr>
-              <a:t>MARKDOWN</a:t>
-            </a:r>
-          </a:p>
-        </p:txBody>
-      </p:sp>
-      <p:sp>
-        <p:nvSpPr>
-          <p:cNvPr id="11" name="">
-            <a:extLst xmlns:a="http://schemas.openxmlformats.org/drawingml/2006/main">
-              <a:ext uri="{FF2B5EF4-FFF2-40B4-BE49-F238E27FC236}">
-                <a16:creationId xmlns:a16="http://schemas.microsoft.com/office/drawing/2014/main" id="{CEDF03DE-623D-471A-80F2-22CF37CB4526}"/>
-              </a:ext>
-            </a:extLst>
-          </p:cNvPr>
-          <p:cNvSpPr>
-            <a:spLocks xmlns:a="http://schemas.openxmlformats.org/drawingml/2006/main" noGrp="1"/>
-          </p:cNvSpPr>
-          <p:nvPr/>
-        </p:nvSpPr>
-        <p:spPr>
-          <a:xfrm xmlns:a="http://schemas.openxmlformats.org/drawingml/2006/main">
-            <a:off x="1047750" y="3733800"/>
-            <a:ext cx="6010275" cy="1752600"/>
-          </a:xfrm>
-          <a:prstGeom xmlns:a="http://schemas.openxmlformats.org/drawingml/2006/main" prst="rect">
-            <a:avLst/>
-          </a:prstGeom>
-          <a:noFill xmlns:a="http://schemas.openxmlformats.org/drawingml/2006/main"/>
-          <a:ln xmlns:a="http://schemas.openxmlformats.org/drawingml/2006/main" w="0">
-            <a:noFill/>
-            <a:prstDash val="solid"/>
-          </a:ln>
-        </p:spPr>
-        <p:txBody>
-          <a:bodyPr xmlns:a="http://schemas.openxmlformats.org/drawingml/2006/main" lIns="0" tIns="0" rIns="0" bIns="0" anchor="t">
-            <a:normAutofit fontScale="95356"/>
-          </a:bodyPr>
-          <a:lstStyle xmlns:a="http://schemas.openxmlformats.org/drawingml/2006/main"/>
-          <a:p xmlns:a="http://schemas.openxmlformats.org/drawingml/2006/main">
-            <a:pPr>
-              <a:lnSpc>
-                <a:spcPct val="115000"/>
-              </a:lnSpc>
-              <a:buNone/>
-              <a:defRPr sz="1200">
-                <a:solidFill>
-                  <a:srgbClr val="F8FAFC"/>
-                </a:solidFill>
-                <a:latin typeface="Menlo"/>
-                <a:ea typeface="Menlo"/>
-                <a:cs typeface="Menlo"/>
-              </a:defRPr>
-            </a:pPr>
-            <a:r>
-              <a:rPr sz="1200">
-                <a:solidFill>
-                  <a:srgbClr val="F8FAFC"/>
-                </a:solidFill>
-                <a:latin typeface="Menlo"/>
-                <a:ea typeface="Menlo"/>
-                <a:cs typeface="Menlo"/>
-              </a:rPr>
-              <a:t># Music service</a:t>
-            </a:r>
-          </a:p>
-          <a:p xmlns:a="http://schemas.openxmlformats.org/drawingml/2006/main">
-            <a:r>
-              <a:t/>
-            </a:r>
-          </a:p>
-          <a:p xmlns:a="http://schemas.openxmlformats.org/drawingml/2006/main">
-            <a:pPr>
-              <a:lnSpc>
-                <a:spcPct val="115000"/>
-              </a:lnSpc>
-              <a:buNone/>
-              <a:defRPr sz="1200">
-                <a:solidFill>
-                  <a:srgbClr val="F8FAFC"/>
-                </a:solidFill>
-                <a:latin typeface="Menlo"/>
-                <a:ea typeface="Menlo"/>
-                <a:cs typeface="Menlo"/>
-              </a:defRPr>
-            </a:pPr>
-            <a:r>
-              <a:rPr sz="1200">
-                <a:solidFill>
-                  <a:srgbClr val="F8FAFC"/>
-                </a:solidFill>
-                <a:latin typeface="Menlo"/>
-                <a:ea typeface="Menlo"/>
-                <a:cs typeface="Menlo"/>
-              </a:rPr>
-              <a:t>## Data</a:t>
-            </a:r>
-          </a:p>
-          <a:p xmlns:a="http://schemas.openxmlformats.org/drawingml/2006/main">
-            <a:pPr>
-              <a:lnSpc>
-                <a:spcPct val="115000"/>
-              </a:lnSpc>
-              <a:buNone/>
-              <a:defRPr sz="1200">
-                <a:solidFill>
-                  <a:srgbClr val="F8FAFC"/>
-                </a:solidFill>
-                <a:latin typeface="Menlo"/>
-                <a:ea typeface="Menlo"/>
-                <a:cs typeface="Menlo"/>
-              </a:defRPr>
-            </a:pPr>
-            <a:r>
-              <a:rPr sz="1200">
-                <a:solidFill>
-                  <a:srgbClr val="F8FAFC"/>
-                </a:solidFill>
-                <a:latin typeface="Menlo"/>
-                <a:ea typeface="Menlo"/>
-                <a:cs typeface="Menlo"/>
-              </a:rPr>
-              <a:t>- users</a:t>
-            </a:r>
-          </a:p>
-          <a:p xmlns:a="http://schemas.openxmlformats.org/drawingml/2006/main">
-            <a:pPr>
-              <a:lnSpc>
-                <a:spcPct val="115000"/>
-              </a:lnSpc>
-              <a:buNone/>
-              <a:defRPr sz="1200">
-                <a:solidFill>
-                  <a:srgbClr val="F8FAFC"/>
-                </a:solidFill>
-                <a:latin typeface="Menlo"/>
-                <a:ea typeface="Menlo"/>
-                <a:cs typeface="Menlo"/>
-              </a:defRPr>
-            </a:pPr>
-            <a:r>
-              <a:rPr sz="1200">
-                <a:solidFill>
-                  <a:srgbClr val="F8FAFC"/>
-                </a:solidFill>
-                <a:latin typeface="Menlo"/>
-                <a:ea typeface="Menlo"/>
-                <a:cs typeface="Menlo"/>
-              </a:rPr>
-              <a:t>- playlists</a:t>
-            </a:r>
-          </a:p>
-          <a:p xmlns:a="http://schemas.openxmlformats.org/drawingml/2006/main">
-            <a:pPr>
-              <a:lnSpc>
-                <a:spcPct val="115000"/>
-              </a:lnSpc>
-              <a:buNone/>
-              <a:defRPr sz="1200">
-                <a:solidFill>
-                  <a:srgbClr val="F8FAFC"/>
-                </a:solidFill>
-                <a:latin typeface="Menlo"/>
-                <a:ea typeface="Menlo"/>
-                <a:cs typeface="Menlo"/>
-              </a:defRPr>
-            </a:pPr>
-            <a:r>
-              <a:rPr sz="1200">
-                <a:solidFill>
-                  <a:srgbClr val="F8FAFC"/>
-                </a:solidFill>
-                <a:latin typeface="Menlo"/>
-                <a:ea typeface="Menlo"/>
-                <a:cs typeface="Menlo"/>
-              </a:rPr>
-              <a:t>- tracks</a:t>
-            </a:r>
-          </a:p>
-          <a:p xmlns:a="http://schemas.openxmlformats.org/drawingml/2006/main">
-            <a:r>
-              <a:t/>
-            </a:r>
-          </a:p>
-          <a:p xmlns:a="http://schemas.openxmlformats.org/drawingml/2006/main">
-            <a:pPr>
-              <a:lnSpc>
-                <a:spcPct val="115000"/>
-              </a:lnSpc>
-              <a:buNone/>
-              <a:defRPr sz="1200">
-                <a:solidFill>
-                  <a:srgbClr val="F8FAFC"/>
-                </a:solidFill>
-                <a:latin typeface="Menlo"/>
-                <a:ea typeface="Menlo"/>
-                <a:cs typeface="Menlo"/>
-              </a:defRPr>
-            </a:pPr>
-            <a:r>
-              <a:rPr sz="1200">
-                <a:solidFill>
-                  <a:srgbClr val="F8FAFC"/>
-                </a:solidFill>
-                <a:latin typeface="Menlo"/>
-                <a:ea typeface="Menlo"/>
-                <a:cs typeface="Menlo"/>
-              </a:rPr>
-              <a:t>## Important question</a:t>
-            </a:r>
-          </a:p>
-          <a:p xmlns:a="http://schemas.openxmlformats.org/drawingml/2006/main">
-            <a:pPr>
-              <a:lnSpc>
-                <a:spcPct val="115000"/>
-              </a:lnSpc>
-              <a:buNone/>
-              <a:defRPr sz="1200">
-                <a:solidFill>
-                  <a:srgbClr val="F8FAFC"/>
-                </a:solidFill>
-                <a:latin typeface="Menlo"/>
-                <a:ea typeface="Menlo"/>
-                <a:cs typeface="Menlo"/>
-              </a:defRPr>
-            </a:pPr>
-            <a:r>
-              <a:rPr sz="1200">
-                <a:solidFill>
-                  <a:srgbClr val="F8FAFC"/>
-                </a:solidFill>
-                <a:latin typeface="Menlo"/>
-                <a:ea typeface="Menlo"/>
-                <a:cs typeface="Menlo"/>
-              </a:rPr>
-              <a:t>Which tracks are in a playlist, in order?</a:t>
-            </a:r>
-          </a:p>
-        </p:txBody>
-      </p:sp>
-      <p:sp>
-        <p:nvSpPr>
-          <p:cNvPr id="12" name="">
-            <a:extLst xmlns:a="http://schemas.openxmlformats.org/drawingml/2006/main">
-              <a:ext uri="{FF2B5EF4-FFF2-40B4-BE49-F238E27FC236}">
-                <a16:creationId xmlns:a16="http://schemas.microsoft.com/office/drawing/2014/main" id="{2B355703-025B-4914-B3C1-808A02FA0C4C}"/>
-              </a:ext>
-            </a:extLst>
-          </p:cNvPr>
-          <p:cNvSpPr>
-            <a:spLocks xmlns:a="http://schemas.openxmlformats.org/drawingml/2006/main" noGrp="1"/>
-          </p:cNvSpPr>
-          <p:nvPr/>
-        </p:nvSpPr>
-        <p:spPr>
-          <a:xfrm xmlns:a="http://schemas.openxmlformats.org/drawingml/2006/main">
-            <a:off x="8048625" y="2190750"/>
-            <a:ext cx="400050" cy="323850"/>
-          </a:xfrm>
-          <a:prstGeom xmlns:a="http://schemas.openxmlformats.org/drawingml/2006/main" prst="roundRect">
-            <a:avLst>
-              <a:gd name="adj" fmla="val 50000"/>
-            </a:avLst>
-          </a:prstGeom>
-          <a:solidFill xmlns:a="http://schemas.openxmlformats.org/drawingml/2006/main">
-            <a:srgbClr val="F4A261"/>
-          </a:solidFill>
-          <a:ln xmlns:a="http://schemas.openxmlformats.org/drawingml/2006/main" w="9525">
-            <a:solidFill>
-              <a:srgbClr val="F4A261"/>
-            </a:solidFill>
-            <a:prstDash val="solid"/>
-          </a:ln>
-        </p:spPr>
-        <p:txBody>
-          <a:bodyPr xmlns:a="http://schemas.openxmlformats.org/drawingml/2006/main" lIns="76200" tIns="0" rIns="76200" bIns="0" anchor="ctr">
-            <a:normAutofit fontScale="100000"/>
-          </a:bodyPr>
-          <a:lstStyle xmlns:a="http://schemas.openxmlformats.org/drawingml/2006/main"/>
-          <a:p xmlns:a="http://schemas.openxmlformats.org/drawingml/2006/main">
-            <a:pPr algn="ctr">
-              <a:buNone/>
-              <a:defRPr sz="1050" b="1">
-                <a:solidFill>
-                  <a:srgbClr val="14213D"/>
-                </a:solidFill>
-                <a:latin typeface="Avenir Next"/>
-                <a:ea typeface="Avenir Next"/>
-                <a:cs typeface="Avenir Next"/>
-              </a:defRPr>
-            </a:pPr>
-            <a:r>
-              <a:rPr sz="1050" b="1">
-                <a:solidFill>
-                  <a:srgbClr val="14213D"/>
-                </a:solidFill>
-                <a:latin typeface="Avenir Next"/>
-                <a:ea typeface="Avenir Next"/>
-                <a:cs typeface="Avenir Next"/>
-              </a:rPr>
-              <a:t>1</a:t>
-            </a:r>
-          </a:p>
-        </p:txBody>
-      </p:sp>
-      <p:sp>
-        <p:nvSpPr>
-          <p:cNvPr id="13" name="">
-            <a:extLst xmlns:a="http://schemas.openxmlformats.org/drawingml/2006/main">
-              <a:ext uri="{FF2B5EF4-FFF2-40B4-BE49-F238E27FC236}">
-                <a16:creationId xmlns:a16="http://schemas.microsoft.com/office/drawing/2014/main" id="{D55D3605-644C-4400-86C2-22BA910C19E6}"/>
-              </a:ext>
-            </a:extLst>
-          </p:cNvPr>
-          <p:cNvSpPr>
-            <a:spLocks xmlns:a="http://schemas.openxmlformats.org/drawingml/2006/main" noGrp="1"/>
-          </p:cNvSpPr>
-          <p:nvPr/>
-        </p:nvSpPr>
-        <p:spPr>
-          <a:xfrm xmlns:a="http://schemas.openxmlformats.org/drawingml/2006/main">
-            <a:off x="8667750" y="2238375"/>
-            <a:ext cx="2809875" cy="476250"/>
-          </a:xfrm>
-          <a:prstGeom xmlns:a="http://schemas.openxmlformats.org/drawingml/2006/main" prst="rect">
-            <a:avLst/>
-          </a:prstGeom>
-          <a:noFill xmlns:a="http://schemas.openxmlformats.org/drawingml/2006/main"/>
-          <a:ln xmlns:a="http://schemas.openxmlformats.org/drawingml/2006/main" w="0">
-            <a:noFill/>
-            <a:prstDash val="solid"/>
-          </a:ln>
-        </p:spPr>
-        <p:txBody>
-          <a:bodyPr xmlns:a="http://schemas.openxmlformats.org/drawingml/2006/main" lIns="0" tIns="0" rIns="0" bIns="0" anchor="t">
-            <a:normAutofit fontScale="100000"/>
-          </a:bodyPr>
-          <a:lstStyle xmlns:a="http://schemas.openxmlformats.org/drawingml/2006/main"/>
-          <a:p xmlns:a="http://schemas.openxmlformats.org/drawingml/2006/main">
-            <a:pPr>
-              <a:buNone/>
-              <a:defRPr sz="1500" b="1">
-                <a:solidFill>
-                  <a:srgbClr val="14213D"/>
-                </a:solidFill>
-                <a:latin typeface="Avenir Next"/>
-                <a:ea typeface="Avenir Next"/>
-                <a:cs typeface="Avenir Next"/>
-              </a:defRPr>
-            </a:pPr>
-            <a:r>
-              <a:rPr sz="1500" b="1">
-                <a:solidFill>
-                  <a:srgbClr val="14213D"/>
-                </a:solidFill>
-                <a:latin typeface="Avenir Next"/>
-                <a:ea typeface="Avenir Next"/>
-                <a:cs typeface="Avenir Next"/>
-              </a:rPr>
-              <a:t>Open the assigned repository</a:t>
-            </a:r>
-          </a:p>
-        </p:txBody>
-      </p:sp>
-      <p:sp>
-        <p:nvSpPr>
-          <p:cNvPr id="14" name="">
-            <a:extLst xmlns:a="http://schemas.openxmlformats.org/drawingml/2006/main">
-              <a:ext uri="{FF2B5EF4-FFF2-40B4-BE49-F238E27FC236}">
-                <a16:creationId xmlns:a16="http://schemas.microsoft.com/office/drawing/2014/main" id="{360D3BD1-55FD-48FD-B7E8-DCC3E405CC3D}"/>
-              </a:ext>
-            </a:extLst>
-          </p:cNvPr>
-          <p:cNvSpPr>
-            <a:spLocks xmlns:a="http://schemas.openxmlformats.org/drawingml/2006/main" noGrp="1"/>
-          </p:cNvSpPr>
-          <p:nvPr/>
-        </p:nvSpPr>
-        <p:spPr>
-          <a:xfrm xmlns:a="http://schemas.openxmlformats.org/drawingml/2006/main">
-            <a:off x="8048625" y="3086100"/>
-            <a:ext cx="400050" cy="323850"/>
-          </a:xfrm>
-          <a:prstGeom xmlns:a="http://schemas.openxmlformats.org/drawingml/2006/main" prst="roundRect">
-            <a:avLst>
-              <a:gd name="adj" fmla="val 50000"/>
-            </a:avLst>
-          </a:prstGeom>
-          <a:solidFill xmlns:a="http://schemas.openxmlformats.org/drawingml/2006/main">
-            <a:srgbClr val="14213D"/>
-          </a:solidFill>
-          <a:ln xmlns:a="http://schemas.openxmlformats.org/drawingml/2006/main" w="9525">
-            <a:solidFill>
-              <a:srgbClr val="14213D"/>
-            </a:solidFill>
-            <a:prstDash val="solid"/>
-          </a:ln>
-        </p:spPr>
-        <p:txBody>
-          <a:bodyPr xmlns:a="http://schemas.openxmlformats.org/drawingml/2006/main" lIns="76200" tIns="0" rIns="76200" bIns="0" anchor="ctr">
-            <a:normAutofit fontScale="100000"/>
-          </a:bodyPr>
-          <a:lstStyle xmlns:a="http://schemas.openxmlformats.org/drawingml/2006/main"/>
-          <a:p xmlns:a="http://schemas.openxmlformats.org/drawingml/2006/main">
-            <a:pPr algn="ctr">
-              <a:buNone/>
-              <a:defRPr sz="1050" b="1">
-                <a:solidFill>
-                  <a:srgbClr val="FFFFFF"/>
-                </a:solidFill>
-                <a:latin typeface="Avenir Next"/>
-                <a:ea typeface="Avenir Next"/>
-                <a:cs typeface="Avenir Next"/>
-              </a:defRPr>
-            </a:pPr>
-            <a:r>
-              <a:rPr sz="1050" b="1">
-                <a:solidFill>
-                  <a:srgbClr val="FFFFFF"/>
-                </a:solidFill>
-                <a:latin typeface="Avenir Next"/>
-                <a:ea typeface="Avenir Next"/>
-                <a:cs typeface="Avenir Next"/>
-              </a:rPr>
-              <a:t>2</a:t>
-            </a:r>
-          </a:p>
-        </p:txBody>
-      </p:sp>
-      <p:sp>
-        <p:nvSpPr>
-          <p:cNvPr id="15" name="">
-            <a:extLst xmlns:a="http://schemas.openxmlformats.org/drawingml/2006/main">
-              <a:ext uri="{FF2B5EF4-FFF2-40B4-BE49-F238E27FC236}">
-                <a16:creationId xmlns:a16="http://schemas.microsoft.com/office/drawing/2014/main" id="{482233B3-9487-4DE9-985A-2427A709FC19}"/>
-              </a:ext>
-            </a:extLst>
-          </p:cNvPr>
-          <p:cNvSpPr>
-            <a:spLocks xmlns:a="http://schemas.openxmlformats.org/drawingml/2006/main" noGrp="1"/>
-          </p:cNvSpPr>
-          <p:nvPr/>
-        </p:nvSpPr>
-        <p:spPr>
-          <a:xfrm xmlns:a="http://schemas.openxmlformats.org/drawingml/2006/main">
-            <a:off x="8667750" y="3133725"/>
-            <a:ext cx="2809875" cy="476250"/>
-          </a:xfrm>
-          <a:prstGeom xmlns:a="http://schemas.openxmlformats.org/drawingml/2006/main" prst="rect">
-            <a:avLst/>
-          </a:prstGeom>
-          <a:noFill xmlns:a="http://schemas.openxmlformats.org/drawingml/2006/main"/>
-          <a:ln xmlns:a="http://schemas.openxmlformats.org/drawingml/2006/main" w="0">
-            <a:noFill/>
-            <a:prstDash val="solid"/>
-          </a:ln>
-        </p:spPr>
-        <p:txBody>
-          <a:bodyPr xmlns:a="http://schemas.openxmlformats.org/drawingml/2006/main" lIns="0" tIns="0" rIns="0" bIns="0" anchor="t">
-            <a:normAutofit fontScale="100000"/>
-          </a:bodyPr>
-          <a:lstStyle xmlns:a="http://schemas.openxmlformats.org/drawingml/2006/main"/>
-          <a:p xmlns:a="http://schemas.openxmlformats.org/drawingml/2006/main">
-            <a:pPr>
-              <a:buNone/>
-              <a:defRPr sz="1500" b="0">
-                <a:solidFill>
-                  <a:srgbClr val="14213D"/>
-                </a:solidFill>
-                <a:latin typeface="Avenir Next"/>
-                <a:ea typeface="Avenir Next"/>
-                <a:cs typeface="Avenir Next"/>
-              </a:defRPr>
-            </a:pPr>
-            <a:r>
-              <a:rPr sz="1500" b="0">
-                <a:solidFill>
-                  <a:srgbClr val="14213D"/>
-                </a:solidFill>
-                <a:latin typeface="Avenir Next"/>
-                <a:ea typeface="Avenir Next"/>
-                <a:cs typeface="Avenir Next"/>
-              </a:rPr>
-              <a:t>Press . or choose Edit</a:t>
-            </a:r>
-          </a:p>
-        </p:txBody>
-      </p:sp>
-      <p:sp>
-        <p:nvSpPr>
-          <p:cNvPr id="16" name="">
-            <a:extLst xmlns:a="http://schemas.openxmlformats.org/drawingml/2006/main">
-              <a:ext uri="{FF2B5EF4-FFF2-40B4-BE49-F238E27FC236}">
-                <a16:creationId xmlns:a16="http://schemas.microsoft.com/office/drawing/2014/main" id="{BDC4B7B2-FD95-4BF0-870B-24CDC275C5FF}"/>
-              </a:ext>
-            </a:extLst>
-          </p:cNvPr>
-          <p:cNvSpPr>
-            <a:spLocks xmlns:a="http://schemas.openxmlformats.org/drawingml/2006/main" noGrp="1"/>
-          </p:cNvSpPr>
-          <p:nvPr/>
-        </p:nvSpPr>
-        <p:spPr>
-          <a:xfrm xmlns:a="http://schemas.openxmlformats.org/drawingml/2006/main">
-            <a:off x="8048625" y="3981450"/>
-            <a:ext cx="400050" cy="323850"/>
-          </a:xfrm>
-          <a:prstGeom xmlns:a="http://schemas.openxmlformats.org/drawingml/2006/main" prst="roundRect">
-            <a:avLst>
-              <a:gd name="adj" fmla="val 50000"/>
-            </a:avLst>
-          </a:prstGeom>
-          <a:solidFill xmlns:a="http://schemas.openxmlformats.org/drawingml/2006/main">
-            <a:srgbClr val="14213D"/>
-          </a:solidFill>
-          <a:ln xmlns:a="http://schemas.openxmlformats.org/drawingml/2006/main" w="9525">
-            <a:solidFill>
-              <a:srgbClr val="14213D"/>
-            </a:solidFill>
-            <a:prstDash val="solid"/>
-          </a:ln>
-        </p:spPr>
-        <p:txBody>
-          <a:bodyPr xmlns:a="http://schemas.openxmlformats.org/drawingml/2006/main" lIns="76200" tIns="0" rIns="76200" bIns="0" anchor="ctr">
-            <a:normAutofit fontScale="100000"/>
-          </a:bodyPr>
-          <a:lstStyle xmlns:a="http://schemas.openxmlformats.org/drawingml/2006/main"/>
-          <a:p xmlns:a="http://schemas.openxmlformats.org/drawingml/2006/main">
-            <a:pPr algn="ctr">
-              <a:buNone/>
-              <a:defRPr sz="1050" b="1">
-                <a:solidFill>
-                  <a:srgbClr val="FFFFFF"/>
-                </a:solidFill>
-                <a:latin typeface="Avenir Next"/>
-                <a:ea typeface="Avenir Next"/>
-                <a:cs typeface="Avenir Next"/>
-              </a:defRPr>
-            </a:pPr>
-            <a:r>
-              <a:rPr sz="1050" b="1">
-                <a:solidFill>
-                  <a:srgbClr val="FFFFFF"/>
-                </a:solidFill>
-                <a:latin typeface="Avenir Next"/>
-                <a:ea typeface="Avenir Next"/>
-                <a:cs typeface="Avenir Next"/>
-              </a:rPr>
-              <a:t>3</a:t>
-            </a:r>
-          </a:p>
-        </p:txBody>
-      </p:sp>
-      <p:sp>
-        <p:nvSpPr>
-          <p:cNvPr id="17" name="">
-            <a:extLst xmlns:a="http://schemas.openxmlformats.org/drawingml/2006/main">
-              <a:ext uri="{FF2B5EF4-FFF2-40B4-BE49-F238E27FC236}">
-                <a16:creationId xmlns:a16="http://schemas.microsoft.com/office/drawing/2014/main" id="{574856AF-E3FC-4859-AE8C-C68989257AEF}"/>
-              </a:ext>
-            </a:extLst>
-          </p:cNvPr>
-          <p:cNvSpPr>
-            <a:spLocks xmlns:a="http://schemas.openxmlformats.org/drawingml/2006/main" noGrp="1"/>
-          </p:cNvSpPr>
-          <p:nvPr/>
-        </p:nvSpPr>
-        <p:spPr>
-          <a:xfrm xmlns:a="http://schemas.openxmlformats.org/drawingml/2006/main">
-            <a:off x="8667750" y="4029075"/>
-            <a:ext cx="2809875" cy="476250"/>
-          </a:xfrm>
-          <a:prstGeom xmlns:a="http://schemas.openxmlformats.org/drawingml/2006/main" prst="rect">
-            <a:avLst/>
-          </a:prstGeom>
-          <a:noFill xmlns:a="http://schemas.openxmlformats.org/drawingml/2006/main"/>
-          <a:ln xmlns:a="http://schemas.openxmlformats.org/drawingml/2006/main" w="0">
-            <a:noFill/>
-            <a:prstDash val="solid"/>
-          </a:ln>
-        </p:spPr>
-        <p:txBody>
-          <a:bodyPr xmlns:a="http://schemas.openxmlformats.org/drawingml/2006/main" lIns="0" tIns="0" rIns="0" bIns="0" anchor="t">
-            <a:normAutofit fontScale="100000"/>
-          </a:bodyPr>
-          <a:lstStyle xmlns:a="http://schemas.openxmlformats.org/drawingml/2006/main"/>
-          <a:p xmlns:a="http://schemas.openxmlformats.org/drawingml/2006/main">
-            <a:pPr>
-              <a:buNone/>
-              <a:defRPr sz="1500" b="0">
-                <a:solidFill>
-                  <a:srgbClr val="14213D"/>
-                </a:solidFill>
-                <a:latin typeface="Avenir Next"/>
-                <a:ea typeface="Avenir Next"/>
-                <a:cs typeface="Avenir Next"/>
-              </a:defRPr>
-            </a:pPr>
-            <a:r>
-              <a:rPr sz="1500" b="0">
-                <a:solidFill>
-                  <a:srgbClr val="14213D"/>
-                </a:solidFill>
-                <a:latin typeface="Avenir Next"/>
-                <a:ea typeface="Avenir Next"/>
-                <a:cs typeface="Avenir Next"/>
-              </a:rPr>
-              <a:t>Create the requested file</a:t>
-            </a:r>
-          </a:p>
-        </p:txBody>
-      </p:sp>
-      <p:sp>
-        <p:nvSpPr>
-          <p:cNvPr id="18" name="">
-            <a:extLst xmlns:a="http://schemas.openxmlformats.org/drawingml/2006/main">
-              <a:ext uri="{FF2B5EF4-FFF2-40B4-BE49-F238E27FC236}">
-                <a16:creationId xmlns:a16="http://schemas.microsoft.com/office/drawing/2014/main" id="{20F9E5AF-E224-4755-8CC1-A930B0132B0C}"/>
-              </a:ext>
-            </a:extLst>
-          </p:cNvPr>
-          <p:cNvSpPr>
-            <a:spLocks xmlns:a="http://schemas.openxmlformats.org/drawingml/2006/main" noGrp="1"/>
-          </p:cNvSpPr>
-          <p:nvPr/>
-        </p:nvSpPr>
-        <p:spPr>
-          <a:xfrm xmlns:a="http://schemas.openxmlformats.org/drawingml/2006/main">
-            <a:off x="8048625" y="4876800"/>
-            <a:ext cx="400050" cy="323850"/>
-          </a:xfrm>
-          <a:prstGeom xmlns:a="http://schemas.openxmlformats.org/drawingml/2006/main" prst="roundRect">
-            <a:avLst>
-              <a:gd name="adj" fmla="val 50000"/>
-            </a:avLst>
-          </a:prstGeom>
-          <a:solidFill xmlns:a="http://schemas.openxmlformats.org/drawingml/2006/main">
-            <a:srgbClr val="14213D"/>
-          </a:solidFill>
-          <a:ln xmlns:a="http://schemas.openxmlformats.org/drawingml/2006/main" w="9525">
-            <a:solidFill>
-              <a:srgbClr val="14213D"/>
-            </a:solidFill>
-            <a:prstDash val="solid"/>
-          </a:ln>
-        </p:spPr>
-        <p:txBody>
-          <a:bodyPr xmlns:a="http://schemas.openxmlformats.org/drawingml/2006/main" lIns="76200" tIns="0" rIns="76200" bIns="0" anchor="ctr">
-            <a:normAutofit fontScale="100000"/>
-          </a:bodyPr>
-          <a:lstStyle xmlns:a="http://schemas.openxmlformats.org/drawingml/2006/main"/>
-          <a:p xmlns:a="http://schemas.openxmlformats.org/drawingml/2006/main">
-            <a:pPr algn="ctr">
-              <a:buNone/>
-              <a:defRPr sz="1050" b="1">
-                <a:solidFill>
-                  <a:srgbClr val="FFFFFF"/>
-                </a:solidFill>
-                <a:latin typeface="Avenir Next"/>
-                <a:ea typeface="Avenir Next"/>
-                <a:cs typeface="Avenir Next"/>
-              </a:defRPr>
-            </a:pPr>
-            <a:r>
-              <a:rPr sz="1050" b="1">
-                <a:solidFill>
-                  <a:srgbClr val="FFFFFF"/>
-                </a:solidFill>
-                <a:latin typeface="Avenir Next"/>
-                <a:ea typeface="Avenir Next"/>
-                <a:cs typeface="Avenir Next"/>
-              </a:rPr>
-              <a:t>4</a:t>
-            </a:r>
-          </a:p>
-        </p:txBody>
-      </p:sp>
-      <p:sp>
-        <p:nvSpPr>
-          <p:cNvPr id="19" name="">
-            <a:extLst xmlns:a="http://schemas.openxmlformats.org/drawingml/2006/main">
-              <a:ext uri="{FF2B5EF4-FFF2-40B4-BE49-F238E27FC236}">
-                <a16:creationId xmlns:a16="http://schemas.microsoft.com/office/drawing/2014/main" id="{622F7195-C75D-400F-BF9B-289BF7FEDDC1}"/>
-              </a:ext>
-            </a:extLst>
-          </p:cNvPr>
-          <p:cNvSpPr>
-            <a:spLocks xmlns:a="http://schemas.openxmlformats.org/drawingml/2006/main" noGrp="1"/>
-          </p:cNvSpPr>
-          <p:nvPr/>
-        </p:nvSpPr>
-        <p:spPr>
-          <a:xfrm xmlns:a="http://schemas.openxmlformats.org/drawingml/2006/main">
-            <a:off x="8667750" y="4924425"/>
-            <a:ext cx="2809875" cy="476250"/>
-          </a:xfrm>
-          <a:prstGeom xmlns:a="http://schemas.openxmlformats.org/drawingml/2006/main" prst="rect">
-            <a:avLst/>
-          </a:prstGeom>
-          <a:noFill xmlns:a="http://schemas.openxmlformats.org/drawingml/2006/main"/>
-          <a:ln xmlns:a="http://schemas.openxmlformats.org/drawingml/2006/main" w="0">
-            <a:noFill/>
-            <a:prstDash val="solid"/>
-          </a:ln>
-        </p:spPr>
-        <p:txBody>
-          <a:bodyPr xmlns:a="http://schemas.openxmlformats.org/drawingml/2006/main" lIns="0" tIns="0" rIns="0" bIns="0" anchor="t">
-            <a:normAutofit fontScale="100000"/>
-          </a:bodyPr>
-          <a:lstStyle xmlns:a="http://schemas.openxmlformats.org/drawingml/2006/main"/>
-          <a:p xmlns:a="http://schemas.openxmlformats.org/drawingml/2006/main">
-            <a:pPr>
-              <a:buNone/>
-              <a:defRPr sz="1500" b="0">
-                <a:solidFill>
-                  <a:srgbClr val="14213D"/>
-                </a:solidFill>
-                <a:latin typeface="Avenir Next"/>
-                <a:ea typeface="Avenir Next"/>
-                <a:cs typeface="Avenir Next"/>
-              </a:defRPr>
-            </a:pPr>
-            <a:r>
-              <a:rPr sz="1500" b="0">
-                <a:solidFill>
-                  <a:srgbClr val="14213D"/>
-                </a:solidFill>
-                <a:latin typeface="Avenir Next"/>
-                <a:ea typeface="Avenir Next"/>
-                <a:cs typeface="Avenir Next"/>
-              </a:rPr>
-              <a:t>Preview, commit, submit its URL</a:t>
-            </a:r>
-          </a:p>
-        </p:txBody>
-      </p:sp>
-    </p:spTree>
-    <p:extLst>
-      <p:ext uri="{BB962C8B-B14F-4D97-AF65-F5344CB8AC3E}">
-        <p14:creationId xmlns:p14="http://schemas.microsoft.com/office/powerpoint/2010/main" val="24404289"/>
       </p:ext>
     </p:extLst>
   </p:cSld>

</xml_diff>